<commit_message>
Redo slide 17: concise findings + recommendation, matching slide style
Removed background fills, used existing color palette (blue headers,
green recommendation, maroon callout), and expanded content to use
full available slide height.
</commit_message>
<xml_diff>
--- a/docs/Capstone_Presentation (10).pptx
+++ b/docs/Capstone_Presentation (10).pptx
@@ -14633,15 +14633,13 @@
         </p:nvSpPr>
         <p:spPr>
           <a:xfrm>
-            <a:off x="297780" y="1137172"/>
-            <a:ext cx="7200000" cy="3600000"/>
+            <a:off x="297780" y="1100000"/>
+            <a:ext cx="7100000" cy="5550000"/>
           </a:xfrm>
           <a:prstGeom prst="roundRect">
             <a:avLst/>
           </a:prstGeom>
-          <a:solidFill>
-            <a:srgbClr val="F5F5F5"/>
-          </a:solidFill>
+          <a:noFill/>
           <a:ln>
             <a:noFill/>
           </a:ln>
@@ -14666,10 +14664,11 @@
           <a:p>
             <a:pPr algn="ctr"/>
             <a:r>
-              <a:rPr sz="1800" b="1">
-                <a:solidFill>
-                  <a:srgbClr val="2D2D2D"/>
-                </a:solidFill>
+              <a:rPr sz="2000" b="1">
+                <a:solidFill>
+                  <a:srgbClr val="0D47A1"/>
+                </a:solidFill>
+                <a:latin typeface="Trust Hartford Sans"/>
               </a:rPr>
               <a:t>Key Findings</a:t>
             </a:r>
@@ -14677,14 +14676,15 @@
           <a:p>
             <a:pPr>
               <a:spcBef>
-                <a:spcPts val="1200"/>
+                <a:spcPts val="1800"/>
               </a:spcBef>
             </a:pPr>
             <a:r>
-              <a:rPr sz="1400" b="1">
+              <a:rPr sz="1600" b="1">
                 <a:solidFill>
                   <a:srgbClr val="0D47A1"/>
                 </a:solidFill>
+                <a:latin typeface="Trust Hartford Sans"/>
               </a:rPr>
               <a:t>1. Weather suppresses trip volume, not price</a:t>
             </a:r>
@@ -14692,29 +14692,31 @@
           <a:p>
             <a:pPr>
               <a:spcBef>
-                <a:spcPts val="200"/>
+                <a:spcPts val="400"/>
               </a:spcBef>
             </a:pPr>
             <a:r>
-              <a:rPr sz="1200" b="0">
-                <a:solidFill>
-                  <a:srgbClr val="555555"/>
-                </a:solidFill>
-              </a:rPr>
-              <a:t>Fares stay flat across all boroughs regardless of conditions. The risk is fewer rides, not cheaper ones.</a:t>
+              <a:rPr sz="1400" b="0">
+                <a:solidFill>
+                  <a:srgbClr val="2F63AF"/>
+                </a:solidFill>
+                <a:latin typeface="Trust Hartford Sans"/>
+              </a:rPr>
+              <a:t>Fares stay flat across all boroughs regardless of conditions. Manhattan: $22.41 clear vs $22.63 adverse. The business risk is fewer rides, not cheaper ones.</a:t>
             </a:r>
           </a:p>
           <a:p>
             <a:pPr>
               <a:spcBef>
-                <a:spcPts val="1200"/>
+                <a:spcPts val="1600"/>
               </a:spcBef>
             </a:pPr>
             <a:r>
-              <a:rPr sz="1400" b="1">
+              <a:rPr sz="1600" b="1">
                 <a:solidFill>
                   <a:srgbClr val="0D47A1"/>
                 </a:solidFill>
+                <a:latin typeface="Trust Hartford Sans"/>
               </a:rPr>
               <a:t>2. Weather's effect on demand flipped year over year</a:t>
             </a:r>
@@ -14722,29 +14724,31 @@
           <a:p>
             <a:pPr>
               <a:spcBef>
-                <a:spcPts val="200"/>
+                <a:spcPts val="400"/>
               </a:spcBef>
             </a:pPr>
             <a:r>
-              <a:rPr sz="1200" b="0">
-                <a:solidFill>
-                  <a:srgbClr val="555555"/>
-                </a:solidFill>
-              </a:rPr>
-              <a:t>In 2025, adverse weather boosted taxi demand. In 2026, it suppressed it.</a:t>
+              <a:rPr sz="1400" b="0">
+                <a:solidFill>
+                  <a:srgbClr val="2F63AF"/>
+                </a:solidFill>
+                <a:latin typeface="Trust Hartford Sans"/>
+              </a:rPr>
+              <a:t>In 2025, adverse weather boosted taxi demand (+3.4%). In 2026, it suppressed it (-2.1%). The relationship is not static.</a:t>
             </a:r>
           </a:p>
           <a:p>
             <a:pPr>
               <a:spcBef>
-                <a:spcPts val="1200"/>
+                <a:spcPts val="1600"/>
               </a:spcBef>
             </a:pPr>
             <a:r>
-              <a:rPr sz="1400" b="1">
+              <a:rPr sz="1600" b="1">
                 <a:solidFill>
                   <a:srgbClr val="0D47A1"/>
                 </a:solidFill>
+                <a:latin typeface="Trust Hartford Sans"/>
               </a:rPr>
               <a:t>3. Snow severity explains the reversal</a:t>
             </a:r>
@@ -14752,29 +14756,31 @@
           <a:p>
             <a:pPr>
               <a:spcBef>
-                <a:spcPts val="200"/>
+                <a:spcPts val="400"/>
               </a:spcBef>
             </a:pPr>
             <a:r>
-              <a:rPr sz="1200" b="0">
-                <a:solidFill>
-                  <a:srgbClr val="555555"/>
-                </a:solidFill>
-              </a:rPr>
-              <a:t>2026 saw 117% more snowfall with 2.5x longer storms. Rain still boosts ridership; heavy snow suppresses it.</a:t>
+              <a:rPr sz="1400" b="0">
+                <a:solidFill>
+                  <a:srgbClr val="2F63AF"/>
+                </a:solidFill>
+                <a:latin typeface="Trust Hartford Sans"/>
+              </a:rPr>
+              <a:t>2026 had 117% more snowfall with 2.5x longer storms. Rain still boosts ridership; severe snow suppresses it entirely.</a:t>
             </a:r>
           </a:p>
           <a:p>
             <a:pPr>
               <a:spcBef>
-                <a:spcPts val="1200"/>
+                <a:spcPts val="1600"/>
               </a:spcBef>
             </a:pPr>
             <a:r>
-              <a:rPr sz="1400" b="1">
+              <a:rPr sz="1600" b="1">
                 <a:solidFill>
                   <a:srgbClr val="0D47A1"/>
                 </a:solidFill>
+                <a:latin typeface="Trust Hartford Sans"/>
               </a:rPr>
               <a:t>4. Revenue losses concentrate in rush hour</a:t>
             </a:r>
@@ -14782,16 +14788,17 @@
           <a:p>
             <a:pPr>
               <a:spcBef>
-                <a:spcPts val="200"/>
+                <a:spcPts val="400"/>
               </a:spcBef>
             </a:pPr>
             <a:r>
-              <a:rPr sz="1200" b="0">
-                <a:solidFill>
-                  <a:srgbClr val="555555"/>
-                </a:solidFill>
-              </a:rPr>
-              <a:t>A single storm-hour during Manhattan rush hour costs $43K+ in lost revenue vs. clear weather.</a:t>
+              <a:rPr sz="1400" b="0">
+                <a:solidFill>
+                  <a:srgbClr val="2F63AF"/>
+                </a:solidFill>
+                <a:latin typeface="Trust Hartford Sans"/>
+              </a:rPr>
+              <a:t>A single storm-hour during Manhattan rush hour represents $43K+ in lost revenue vs. clear weather.</a:t>
             </a:r>
           </a:p>
         </p:txBody>
@@ -14804,15 +14811,13 @@
         </p:nvSpPr>
         <p:spPr>
           <a:xfrm>
-            <a:off x="7700000" y="1137172"/>
-            <a:ext cx="4200000" cy="3600000"/>
+            <a:off x="7577780" y="1100000"/>
+            <a:ext cx="4316440" cy="5550000"/>
           </a:xfrm>
           <a:prstGeom prst="roundRect">
             <a:avLst/>
           </a:prstGeom>
-          <a:solidFill>
-            <a:srgbClr val="E8F5E9"/>
-          </a:solidFill>
+          <a:noFill/>
           <a:ln>
             <a:noFill/>
           </a:ln>
@@ -14837,12 +14842,29 @@
           <a:p>
             <a:pPr algn="ctr"/>
             <a:r>
-              <a:rPr sz="1800" b="1">
+              <a:rPr sz="2000" b="1">
                 <a:solidFill>
                   <a:srgbClr val="2E7D32"/>
                 </a:solidFill>
+                <a:latin typeface="Trust Hartford Sans"/>
               </a:rPr>
               <a:t>Recommendation</a:t>
+            </a:r>
+          </a:p>
+          <a:p>
+            <a:pPr>
+              <a:spcBef>
+                <a:spcPts val="1800"/>
+              </a:spcBef>
+            </a:pPr>
+            <a:r>
+              <a:rPr sz="1500" b="1">
+                <a:solidFill>
+                  <a:srgbClr val="2E7D32"/>
+                </a:solidFill>
+                <a:latin typeface="Trust Hartford Sans"/>
+              </a:rPr>
+              <a:t>Implement weather-triggered fleet deployment:</a:t>
             </a:r>
           </a:p>
           <a:p>
@@ -14852,72 +14874,61 @@
               </a:spcBef>
             </a:pPr>
             <a:r>
-              <a:rPr sz="1300" b="1">
+              <a:rPr sz="1400" b="0">
                 <a:solidFill>
                   <a:srgbClr val="2D805D"/>
                 </a:solidFill>
-              </a:rPr>
-              <a:t>Implement weather-triggered fleet deployment:</a:t>
+                <a:latin typeface="Trust Hartford Sans"/>
+              </a:rPr>
+              <a:t>Pre-position vehicles in high-demand zones before forecasted storms</a:t>
             </a:r>
           </a:p>
           <a:p>
             <a:pPr>
               <a:spcBef>
-                <a:spcPts val="800"/>
+                <a:spcPts val="1000"/>
               </a:spcBef>
             </a:pPr>
             <a:r>
-              <a:rPr sz="1200" b="0">
+              <a:rPr sz="1400" b="0">
                 <a:solidFill>
                   <a:srgbClr val="2D805D"/>
                 </a:solidFill>
-              </a:rPr>
-              <a:t>1. Pre-position vehicles in high-demand zones before forecasted storms</a:t>
+                <a:latin typeface="Trust Hartford Sans"/>
+              </a:rPr>
+              <a:t>Prioritize rush-hour coverage where revenue impact is greatest</a:t>
             </a:r>
           </a:p>
           <a:p>
             <a:pPr>
               <a:spcBef>
-                <a:spcPts val="600"/>
+                <a:spcPts val="1000"/>
               </a:spcBef>
             </a:pPr>
             <a:r>
-              <a:rPr sz="1200" b="0">
+              <a:rPr sz="1400" b="0">
                 <a:solidFill>
                   <a:srgbClr val="2D805D"/>
                 </a:solidFill>
-              </a:rPr>
-              <a:t>2. Prioritize rush-hour coverage where revenue loss is greatest</a:t>
+                <a:latin typeface="Trust Hartford Sans"/>
+              </a:rPr>
+              <a:t>Use dynamic driver incentives during severe snow events</a:t>
             </a:r>
           </a:p>
           <a:p>
             <a:pPr>
               <a:spcBef>
-                <a:spcPts val="600"/>
+                <a:spcPts val="2400"/>
               </a:spcBef>
             </a:pPr>
             <a:r>
-              <a:rPr sz="1200" b="0">
-                <a:solidFill>
-                  <a:srgbClr val="2D805D"/>
-                </a:solidFill>
-              </a:rPr>
-              <a:t>3. Use dynamic incentives to keep drivers on the road during severe snow</a:t>
-            </a:r>
-          </a:p>
-          <a:p>
-            <a:pPr>
-              <a:spcBef>
-                <a:spcPts val="1400"/>
-              </a:spcBef>
-            </a:pPr>
-            <a:r>
-              <a:rPr sz="1300" b="1">
+              <a:rPr sz="1500" b="1">
                 <a:solidFill>
                   <a:srgbClr val="2E7D32"/>
                 </a:solidFill>
-              </a:rPr>
-              <a:t>Focus on when, not if.</a:t>
+                <a:latin typeface="Trust Hartford Sans"/>
+              </a:rPr>
+              <a:t>Why This Works</a:t>
             </a:r>
           </a:p>
           <a:p>
@@ -14927,63 +14938,45 @@
               </a:spcBef>
             </a:pPr>
             <a:r>
-              <a:rPr sz="1200" b="0">
+              <a:rPr sz="1400" b="0">
                 <a:solidFill>
                   <a:srgbClr val="2D805D"/>
                 </a:solidFill>
-              </a:rPr>
-              <a:t>The data shows it's not about whether weather hurts demand. It's about protecting the highest-value hours.</a:t>
-            </a:r>
-          </a:p>
-        </p:txBody>
-      </p:sp>
-      <p:sp>
-        <p:nvSpPr>
-          <p:cNvPr id="7" name="Rounded Rectangle 6"/>
-          <p:cNvSpPr/>
-          <p:nvPr/>
-        </p:nvSpPr>
-        <p:spPr>
-          <a:xfrm>
-            <a:off x="297780" y="4937172"/>
-            <a:ext cx="11600000" cy="700000"/>
-          </a:xfrm>
-          <a:prstGeom prst="roundRect">
-            <a:avLst/>
-          </a:prstGeom>
-          <a:solidFill>
-            <a:srgbClr val="8B0138"/>
-          </a:solidFill>
-          <a:ln>
-            <a:noFill/>
-          </a:ln>
-        </p:spPr>
-        <p:style>
-          <a:lnRef idx="1">
-            <a:schemeClr val="accent1"/>
-          </a:lnRef>
-          <a:fillRef idx="3">
-            <a:schemeClr val="accent1"/>
-          </a:fillRef>
-          <a:effectRef idx="2">
-            <a:schemeClr val="accent1"/>
-          </a:effectRef>
-          <a:fontRef idx="minor">
-            <a:schemeClr val="lt1"/>
-          </a:fontRef>
-        </p:style>
-        <p:txBody>
-          <a:bodyPr rtlCol="0" anchor="ctr" wrap="square"/>
-          <a:lstStyle/>
-          <a:p>
-            <a:pPr algn="ctr"/>
-            <a:r>
-              <a:rPr sz="1300" b="1">
-                <a:solidFill>
-                  <a:srgbClr val="FFFFFF"/>
-                </a:solidFill>
-              </a:rPr>
-              <a:t>Bottom Line: Weather doesn't change what a ride costs. It changes how many rides happen, and that impact is concentrated in the hours that matter most.</a:t>
+                <a:latin typeface="Trust Hartford Sans"/>
+              </a:rPr>
+              <a:t>The data shows weather impact is predictable and concentrated. Operators who staff for storms during peak hours recover the most revenue with the least operational cost.</a:t>
+            </a:r>
+          </a:p>
+          <a:p>
+            <a:pPr>
+              <a:spcBef>
+                <a:spcPts val="2400"/>
+              </a:spcBef>
+            </a:pPr>
+            <a:r>
+              <a:rPr sz="1600" b="1">
+                <a:solidFill>
+                  <a:srgbClr val="8B0138"/>
+                </a:solidFill>
+                <a:latin typeface="Trust Hartford Sans"/>
+              </a:rPr>
+              <a:t>Focus on when, not if.</a:t>
+            </a:r>
+          </a:p>
+          <a:p>
+            <a:pPr>
+              <a:spcBef>
+                <a:spcPts val="400"/>
+              </a:spcBef>
+            </a:pPr>
+            <a:r>
+              <a:rPr sz="1400" b="0">
+                <a:solidFill>
+                  <a:srgbClr val="8B0138"/>
+                </a:solidFill>
+                <a:latin typeface="Trust Hartford Sans"/>
+              </a:rPr>
+              <a:t>It's not about whether weather hurts demand. It's about protecting the highest-value hours.</a:t>
             </a:r>
           </a:p>
         </p:txBody>

</xml_diff>

<commit_message>
Rebuild slide 17 with data-backed driver recommendations
Three-card layout matching Future State slide style: green/blue/orange
cards with maroon callout bar. Content based on actual revenue-per-minute
analysis by borough and weather condition.
</commit_message>
<xml_diff>
--- a/docs/Capstone_Presentation (10).pptx
+++ b/docs/Capstone_Presentation (10).pptx
@@ -2199,7 +2199,11 @@
           <a:lstStyle/>
           <a:p>
             <a:r>
-              <a:t>ORLANDO: To bring it all together: our analysis showed four clear findings. First, weather impacts trip volume but not pricing. Fares stay essentially flat regardless of conditions. Second, the relationship between weather and demand is not static. In 2025, bad weather actually boosted taxi usage, but in 2026, it suppressed it. Third, that reversal is explained by snow severity. 2026 had dramatically worse winter storms that crossed a threshold from inconvenient to impassable. And fourth, the revenue impact is not spread evenly. It concentrates heavily during rush hour, where a single storm-hour in Manhattan costs over $43,000 in lost revenue. Our recommendation is to implement weather-triggered fleet deployment: pre-position vehicles before storms, prioritize rush-hour coverage, and use driver incentives during severe snow. The key insight is that it's not about whether weather hurts demand. It's about protecting the highest-value hours.</a:t>
+              <a:t>ORLANDO: So what should taxi drivers actually do with this information? Our data supports three clear recommendations.
+First, when it rains, get to Brooklyn. Brooklyn is the only borough where both demand and earnings efficiency increase during rain. Demand surges 27 percent, from 188 to 238 trips per hour, and per-minute earnings rise 11 percent. No other borough shows that combination.
+Second, when it snows, stay on the road. This might sound counterintuitive because total trip volume drops during snow. But the drivers who remain available earn more per active minute of driving, in every single borough, ranging from 7 percent more in Manhattan to 29 percent more in the Bronx. In Manhattan specifically, that translates to roughly 76 dollars per hour versus 71 during clear weather. Fewer drivers on the road means less competition for the fares that are still available.
+Third, during clear weather, which accounts for 94.5 percent of all operating hours, prioritize Manhattan for volume consistency. At over 4,500 trips per hour, Manhattan offers 10 times the trip density of the next borough, which means minimal downtime between fares. This is where the majority of annual income is generated.
+The bottom line is that each weather condition calls for a different strategy. Rain is an opportunity, snow rewards those who stay, and clear weather is about steady volume.</a:t>
             </a:r>
           </a:p>
         </p:txBody>
@@ -14569,7 +14573,6 @@
           <a:lstStyle/>
           <a:p>
             <a:r>
-              <a:rPr lang="en-US"/>
               <a:t>Summary and Recommendation</a:t>
             </a:r>
           </a:p>
@@ -14633,13 +14636,15 @@
         </p:nvSpPr>
         <p:spPr>
           <a:xfrm>
-            <a:off x="297780" y="1100000"/>
-            <a:ext cx="7100000" cy="5550000"/>
+            <a:off x="400000" y="1000000"/>
+            <a:ext cx="3600000" cy="4800000"/>
           </a:xfrm>
           <a:prstGeom prst="roundRect">
             <a:avLst/>
           </a:prstGeom>
-          <a:noFill/>
+          <a:solidFill>
+            <a:srgbClr val="E8F5E9"/>
+          </a:solidFill>
           <a:ln>
             <a:noFill/>
           </a:ln>
@@ -14659,146 +14664,98 @@
           </a:fontRef>
         </p:style>
         <p:txBody>
-          <a:bodyPr rtlCol="0" anchor="ctr" wrap="square"/>
+          <a:bodyPr rtlCol="0" anchor="ctr" lIns="180000" tIns="180000" rIns="180000" bIns="90000" wrap="square"/>
           <a:lstStyle/>
           <a:p>
             <a:pPr algn="ctr"/>
             <a:r>
-              <a:rPr sz="2000" b="1">
-                <a:solidFill>
-                  <a:srgbClr val="0D47A1"/>
+              <a:rPr sz="1600" b="1">
+                <a:solidFill>
+                  <a:srgbClr val="2E7D32"/>
                 </a:solidFill>
                 <a:latin typeface="Trust Hartford Sans"/>
               </a:rPr>
-              <a:t>Key Findings</a:t>
+              <a:t>When It Rains, Get to Brooklyn</a:t>
             </a:r>
           </a:p>
           <a:p>
             <a:pPr>
               <a:spcBef>
-                <a:spcPts val="1800"/>
+                <a:spcPts val="1400"/>
               </a:spcBef>
             </a:pPr>
             <a:r>
-              <a:rPr sz="1600" b="1">
-                <a:solidFill>
-                  <a:srgbClr val="0D47A1"/>
+              <a:rPr sz="1400" b="1">
+                <a:solidFill>
+                  <a:srgbClr val="2D805D"/>
                 </a:solidFill>
                 <a:latin typeface="Trust Hartford Sans"/>
               </a:rPr>
-              <a:t>1. Weather suppresses trip volume, not price</a:t>
+              <a:t>The Data</a:t>
             </a:r>
           </a:p>
           <a:p>
             <a:pPr>
               <a:spcBef>
-                <a:spcPts val="400"/>
+                <a:spcPts val="600"/>
               </a:spcBef>
             </a:pPr>
             <a:r>
               <a:rPr sz="1400" b="0">
                 <a:solidFill>
-                  <a:srgbClr val="2F63AF"/>
+                  <a:srgbClr val="2D805D"/>
                 </a:solidFill>
                 <a:latin typeface="Trust Hartford Sans"/>
               </a:rPr>
-              <a:t>Fares stay flat across all boroughs regardless of conditions. Manhattan: $22.41 clear vs $22.63 adverse. The business risk is fewer rides, not cheaper ones.</a:t>
+              <a:t>Brooklyn demand surges +27% during rain (188 → 238 trips/hr)</a:t>
             </a:r>
           </a:p>
           <a:p>
             <a:pPr>
               <a:spcBef>
-                <a:spcPts val="1600"/>
+                <a:spcPts val="600"/>
               </a:spcBef>
             </a:pPr>
             <a:r>
-              <a:rPr sz="1600" b="1">
-                <a:solidFill>
-                  <a:srgbClr val="0D47A1"/>
+              <a:rPr sz="1400" b="0">
+                <a:solidFill>
+                  <a:srgbClr val="2D805D"/>
                 </a:solidFill>
                 <a:latin typeface="Trust Hartford Sans"/>
               </a:rPr>
-              <a:t>2. Weather's effect on demand flipped year over year</a:t>
+              <a:t>Per-minute earnings rise +11% ($1.16 → $1.29/min)</a:t>
             </a:r>
           </a:p>
           <a:p>
             <a:pPr>
               <a:spcBef>
-                <a:spcPts val="400"/>
+                <a:spcPts val="1400"/>
               </a:spcBef>
             </a:pPr>
             <a:r>
-              <a:rPr sz="1400" b="0">
-                <a:solidFill>
-                  <a:srgbClr val="2F63AF"/>
+              <a:rPr sz="1400" b="1">
+                <a:solidFill>
+                  <a:srgbClr val="2D805D"/>
                 </a:solidFill>
                 <a:latin typeface="Trust Hartford Sans"/>
               </a:rPr>
-              <a:t>In 2025, adverse weather boosted taxi demand (+3.4%). In 2026, it suppressed it (-2.1%). The relationship is not static.</a:t>
+              <a:t>Why It Matters</a:t>
             </a:r>
           </a:p>
           <a:p>
             <a:pPr>
               <a:spcBef>
-                <a:spcPts val="1600"/>
+                <a:spcPts val="600"/>
               </a:spcBef>
             </a:pPr>
             <a:r>
-              <a:rPr sz="1600" b="1">
-                <a:solidFill>
-                  <a:srgbClr val="0D47A1"/>
+              <a:rPr sz="1400" b="0">
+                <a:solidFill>
+                  <a:srgbClr val="2D805D"/>
                 </a:solidFill>
                 <a:latin typeface="Trust Hartford Sans"/>
               </a:rPr>
-              <a:t>3. Snow severity explains the reversal</a:t>
-            </a:r>
-          </a:p>
-          <a:p>
-            <a:pPr>
-              <a:spcBef>
-                <a:spcPts val="400"/>
-              </a:spcBef>
-            </a:pPr>
-            <a:r>
-              <a:rPr sz="1400" b="0">
-                <a:solidFill>
-                  <a:srgbClr val="2F63AF"/>
-                </a:solidFill>
-                <a:latin typeface="Trust Hartford Sans"/>
-              </a:rPr>
-              <a:t>2026 had 117% more snowfall with 2.5x longer storms. Rain still boosts ridership; severe snow suppresses it entirely.</a:t>
-            </a:r>
-          </a:p>
-          <a:p>
-            <a:pPr>
-              <a:spcBef>
-                <a:spcPts val="1600"/>
-              </a:spcBef>
-            </a:pPr>
-            <a:r>
-              <a:rPr sz="1600" b="1">
-                <a:solidFill>
-                  <a:srgbClr val="0D47A1"/>
-                </a:solidFill>
-                <a:latin typeface="Trust Hartford Sans"/>
-              </a:rPr>
-              <a:t>4. Revenue losses concentrate in rush hour</a:t>
-            </a:r>
-          </a:p>
-          <a:p>
-            <a:pPr>
-              <a:spcBef>
-                <a:spcPts val="400"/>
-              </a:spcBef>
-            </a:pPr>
-            <a:r>
-              <a:rPr sz="1400" b="0">
-                <a:solidFill>
-                  <a:srgbClr val="2F63AF"/>
-                </a:solidFill>
-                <a:latin typeface="Trust Hartford Sans"/>
-              </a:rPr>
-              <a:t>A single storm-hour during Manhattan rush hour represents $43K+ in lost revenue vs. clear weather.</a:t>
+              <a:t>Brooklyn is the only borough where both volume and earnings efficiency increase during rain</a:t>
             </a:r>
           </a:p>
         </p:txBody>
@@ -14811,13 +14768,15 @@
         </p:nvSpPr>
         <p:spPr>
           <a:xfrm>
-            <a:off x="7577780" y="1100000"/>
-            <a:ext cx="4316440" cy="5550000"/>
+            <a:off x="4300000" y="1000000"/>
+            <a:ext cx="3600000" cy="4800000"/>
           </a:xfrm>
           <a:prstGeom prst="roundRect">
             <a:avLst/>
           </a:prstGeom>
-          <a:noFill/>
+          <a:solidFill>
+            <a:srgbClr val="E3F2FD"/>
+          </a:solidFill>
           <a:ln>
             <a:noFill/>
           </a:ln>
@@ -14837,34 +14796,18 @@
           </a:fontRef>
         </p:style>
         <p:txBody>
-          <a:bodyPr rtlCol="0" anchor="ctr" wrap="square"/>
+          <a:bodyPr rtlCol="0" anchor="ctr" lIns="180000" tIns="180000" rIns="180000" bIns="90000" wrap="square"/>
           <a:lstStyle/>
           <a:p>
             <a:pPr algn="ctr"/>
             <a:r>
-              <a:rPr sz="2000" b="1">
-                <a:solidFill>
-                  <a:srgbClr val="2E7D32"/>
+              <a:rPr sz="1600" b="1">
+                <a:solidFill>
+                  <a:srgbClr val="0D47A1"/>
                 </a:solidFill>
                 <a:latin typeface="Trust Hartford Sans"/>
               </a:rPr>
-              <a:t>Recommendation</a:t>
-            </a:r>
-          </a:p>
-          <a:p>
-            <a:pPr>
-              <a:spcBef>
-                <a:spcPts val="1800"/>
-              </a:spcBef>
-            </a:pPr>
-            <a:r>
-              <a:rPr sz="1500" b="1">
-                <a:solidFill>
-                  <a:srgbClr val="2E7D32"/>
-                </a:solidFill>
-                <a:latin typeface="Trust Hartford Sans"/>
-              </a:rPr>
-              <a:t>Implement weather-triggered fleet deployment:</a:t>
+              <a:t>When It Snows, Stay on the Road</a:t>
             </a:r>
           </a:p>
           <a:p>
@@ -14874,109 +14817,261 @@
               </a:spcBef>
             </a:pPr>
             <a:r>
-              <a:rPr sz="1400" b="0">
-                <a:solidFill>
-                  <a:srgbClr val="2D805D"/>
+              <a:rPr sz="1400" b="1">
+                <a:solidFill>
+                  <a:srgbClr val="0D47A1"/>
                 </a:solidFill>
                 <a:latin typeface="Trust Hartford Sans"/>
               </a:rPr>
-              <a:t>Pre-position vehicles in high-demand zones before forecasted storms</a:t>
+              <a:t>The Data</a:t>
             </a:r>
           </a:p>
           <a:p>
             <a:pPr>
               <a:spcBef>
-                <a:spcPts val="1000"/>
+                <a:spcPts val="600"/>
               </a:spcBef>
             </a:pPr>
             <a:r>
               <a:rPr sz="1400" b="0">
                 <a:solidFill>
-                  <a:srgbClr val="2D805D"/>
+                  <a:srgbClr val="2F63AF"/>
                 </a:solidFill>
                 <a:latin typeface="Trust Hartford Sans"/>
               </a:rPr>
-              <a:t>Prioritize rush-hour coverage where revenue impact is greatest</a:t>
+              <a:t>Earnings per active minute rise in every borough during snow (+7% to +29%)</a:t>
             </a:r>
           </a:p>
           <a:p>
             <a:pPr>
               <a:spcBef>
-                <a:spcPts val="1000"/>
+                <a:spcPts val="600"/>
               </a:spcBef>
             </a:pPr>
             <a:r>
               <a:rPr sz="1400" b="0">
                 <a:solidFill>
-                  <a:srgbClr val="2D805D"/>
+                  <a:srgbClr val="2F63AF"/>
                 </a:solidFill>
                 <a:latin typeface="Trust Hartford Sans"/>
               </a:rPr>
-              <a:t>Use dynamic driver incentives during severe snow events</a:t>
+              <a:t>Manhattan snow: $76/hr vs $71/hr clear weather</a:t>
             </a:r>
           </a:p>
           <a:p>
             <a:pPr>
               <a:spcBef>
-                <a:spcPts val="2400"/>
+                <a:spcPts val="1400"/>
               </a:spcBef>
             </a:pPr>
             <a:r>
-              <a:rPr sz="1500" b="1">
-                <a:solidFill>
-                  <a:srgbClr val="2E7D32"/>
+              <a:rPr sz="1400" b="1">
+                <a:solidFill>
+                  <a:srgbClr val="0D47A1"/>
                 </a:solidFill>
                 <a:latin typeface="Trust Hartford Sans"/>
               </a:rPr>
-              <a:t>Why This Works</a:t>
+              <a:t>Why It Matters</a:t>
             </a:r>
           </a:p>
           <a:p>
             <a:pPr>
               <a:spcBef>
-                <a:spcPts val="400"/>
+                <a:spcPts val="600"/>
               </a:spcBef>
             </a:pPr>
             <a:r>
               <a:rPr sz="1400" b="0">
                 <a:solidFill>
-                  <a:srgbClr val="2D805D"/>
+                  <a:srgbClr val="2F63AF"/>
                 </a:solidFill>
                 <a:latin typeface="Trust Hartford Sans"/>
               </a:rPr>
-              <a:t>The data shows weather impact is predictable and concentrated. Operators who staff for storms during peak hours recover the most revenue with the least operational cost.</a:t>
+              <a:t>Drivers who remain available during snow face less competition and earn more per minute of driving time</a:t>
+            </a:r>
+          </a:p>
+        </p:txBody>
+      </p:sp>
+      <p:sp>
+        <p:nvSpPr>
+          <p:cNvPr id="7" name="Rounded Rectangle 6"/>
+          <p:cNvSpPr/>
+          <p:nvPr/>
+        </p:nvSpPr>
+        <p:spPr>
+          <a:xfrm>
+            <a:off x="8200000" y="1000000"/>
+            <a:ext cx="3600000" cy="4800000"/>
+          </a:xfrm>
+          <a:prstGeom prst="roundRect">
+            <a:avLst/>
+          </a:prstGeom>
+          <a:solidFill>
+            <a:srgbClr val="FFF3E0"/>
+          </a:solidFill>
+          <a:ln>
+            <a:noFill/>
+          </a:ln>
+        </p:spPr>
+        <p:style>
+          <a:lnRef idx="1">
+            <a:schemeClr val="accent1"/>
+          </a:lnRef>
+          <a:fillRef idx="3">
+            <a:schemeClr val="accent1"/>
+          </a:fillRef>
+          <a:effectRef idx="2">
+            <a:schemeClr val="accent1"/>
+          </a:effectRef>
+          <a:fontRef idx="minor">
+            <a:schemeClr val="lt1"/>
+          </a:fontRef>
+        </p:style>
+        <p:txBody>
+          <a:bodyPr rtlCol="0" anchor="ctr" lIns="180000" tIns="180000" rIns="180000" bIns="90000" wrap="square"/>
+          <a:lstStyle/>
+          <a:p>
+            <a:pPr algn="ctr"/>
+            <a:r>
+              <a:rPr sz="1600" b="1">
+                <a:solidFill>
+                  <a:srgbClr val="E65100"/>
+                </a:solidFill>
+                <a:latin typeface="Trust Hartford Sans"/>
+              </a:rPr>
+              <a:t>Clear Weather: Maximize Manhattan Volume</a:t>
             </a:r>
           </a:p>
           <a:p>
             <a:pPr>
               <a:spcBef>
-                <a:spcPts val="2400"/>
+                <a:spcPts val="1400"/>
               </a:spcBef>
             </a:pPr>
             <a:r>
-              <a:rPr sz="1600" b="1">
-                <a:solidFill>
-                  <a:srgbClr val="8B0138"/>
+              <a:rPr sz="1400" b="1">
+                <a:solidFill>
+                  <a:srgbClr val="E65100"/>
                 </a:solidFill>
                 <a:latin typeface="Trust Hartford Sans"/>
               </a:rPr>
-              <a:t>Focus on when, not if.</a:t>
+              <a:t>The Data</a:t>
             </a:r>
           </a:p>
           <a:p>
             <a:pPr>
               <a:spcBef>
-                <a:spcPts val="400"/>
+                <a:spcPts val="600"/>
               </a:spcBef>
             </a:pPr>
             <a:r>
               <a:rPr sz="1400" b="0">
                 <a:solidFill>
-                  <a:srgbClr val="8B0138"/>
+                  <a:srgbClr val="E65100"/>
                 </a:solidFill>
                 <a:latin typeface="Trust Hartford Sans"/>
               </a:rPr>
-              <a:t>It's not about whether weather hurts demand. It's about protecting the highest-value hours.</a:t>
+              <a:t>4,539 trips/hr in Manhattan (10x any other borough)</a:t>
+            </a:r>
+          </a:p>
+          <a:p>
+            <a:pPr>
+              <a:spcBef>
+                <a:spcPts val="600"/>
+              </a:spcBef>
+            </a:pPr>
+            <a:r>
+              <a:rPr sz="1400" b="0">
+                <a:solidFill>
+                  <a:srgbClr val="E65100"/>
+                </a:solidFill>
+                <a:latin typeface="Trust Hartford Sans"/>
+              </a:rPr>
+              <a:t>Clear weather accounts for 94.5% of all operating hours</a:t>
+            </a:r>
+          </a:p>
+          <a:p>
+            <a:pPr>
+              <a:spcBef>
+                <a:spcPts val="1400"/>
+              </a:spcBef>
+            </a:pPr>
+            <a:r>
+              <a:rPr sz="1400" b="1">
+                <a:solidFill>
+                  <a:srgbClr val="E65100"/>
+                </a:solidFill>
+                <a:latin typeface="Trust Hartford Sans"/>
+              </a:rPr>
+              <a:t>Why It Matters</a:t>
+            </a:r>
+          </a:p>
+          <a:p>
+            <a:pPr>
+              <a:spcBef>
+                <a:spcPts val="600"/>
+              </a:spcBef>
+            </a:pPr>
+            <a:r>
+              <a:rPr sz="1400" b="0">
+                <a:solidFill>
+                  <a:srgbClr val="E65100"/>
+                </a:solidFill>
+                <a:latin typeface="Trust Hartford Sans"/>
+              </a:rPr>
+              <a:t>The majority of annual income is earned during clear conditions. Consistent volume minimizes downtime between fares.</a:t>
+            </a:r>
+          </a:p>
+        </p:txBody>
+      </p:sp>
+      <p:sp>
+        <p:nvSpPr>
+          <p:cNvPr id="8" name="Rounded Rectangle 7"/>
+          <p:cNvSpPr/>
+          <p:nvPr/>
+        </p:nvSpPr>
+        <p:spPr>
+          <a:xfrm>
+            <a:off x="400000" y="6000000"/>
+            <a:ext cx="11400000" cy="600000"/>
+          </a:xfrm>
+          <a:prstGeom prst="roundRect">
+            <a:avLst/>
+          </a:prstGeom>
+          <a:solidFill>
+            <a:srgbClr val="8B0138"/>
+          </a:solidFill>
+          <a:ln>
+            <a:noFill/>
+          </a:ln>
+        </p:spPr>
+        <p:style>
+          <a:lnRef idx="1">
+            <a:schemeClr val="accent1"/>
+          </a:lnRef>
+          <a:fillRef idx="3">
+            <a:schemeClr val="accent1"/>
+          </a:fillRef>
+          <a:effectRef idx="2">
+            <a:schemeClr val="accent1"/>
+          </a:effectRef>
+          <a:fontRef idx="minor">
+            <a:schemeClr val="lt1"/>
+          </a:fontRef>
+        </p:style>
+        <p:txBody>
+          <a:bodyPr rtlCol="0" anchor="ctr" lIns="200000" tIns="120000" rIns="180000" bIns="90000" wrap="square"/>
+          <a:lstStyle/>
+          <a:p>
+            <a:pPr algn="ctr"/>
+            <a:r>
+              <a:rPr sz="1300" b="1">
+                <a:solidFill>
+                  <a:srgbClr val="FFFFFF"/>
+                </a:solidFill>
+                <a:latin typeface="Trust Hartford Sans"/>
+              </a:rPr>
+              <a:t>Each weather condition calls for a different positioning strategy. Rain is an opportunity, snow rewards persistence, and clear weather is about volume consistency.</a:t>
             </a:r>
           </a:p>
         </p:txBody>

</xml_diff>

<commit_message>
Add Queens to clear weather recommendation on slide 17
Queens offers 15% earnings premium over Manhattan ($82/hr vs $71/hr)
with longer, higher-fare trips. Card now presents both options with
supporting data.
</commit_message>
<xml_diff>
--- a/docs/Capstone_Presentation (10).pptx
+++ b/docs/Capstone_Presentation (10).pptx
@@ -2202,8 +2202,8 @@
               <a:t>ORLANDO: So what should taxi drivers actually do with this information? Our data supports three clear recommendations.
 First, when it rains, get to Brooklyn. Brooklyn is the only borough where both demand and earnings efficiency increase during rain. Demand surges 27 percent, from 188 to 238 trips per hour, and per-minute earnings rise 11 percent. No other borough shows that combination.
 Second, when it snows, stay on the road. This might sound counterintuitive because total trip volume drops during snow. But the drivers who remain available earn more per active minute of driving, in every single borough, ranging from 7 percent more in Manhattan to 29 percent more in the Bronx. In Manhattan specifically, that translates to roughly 76 dollars per hour versus 71 during clear weather. Fewer drivers on the road means less competition for the fares that are still available.
-Third, during clear weather, which accounts for 94.5 percent of all operating hours, prioritize Manhattan for volume consistency. At over 4,500 trips per hour, Manhattan offers 10 times the trip density of the next borough, which means minimal downtime between fares. This is where the majority of annual income is generated.
-The bottom line is that each weather condition calls for a different strategy. Rain is an opportunity, snow rewards those who stay, and clear weather is about steady volume.</a:t>
+Third, during clear weather, which accounts for 94.5 percent of all operating hours, drivers have two strong options. Manhattan offers unmatched volume at over 4,500 trips per hour, meaning minimal idle time between fares and consistent 71-dollar-per-hour earnings. Queens, on the other hand, offers a 15 percent earnings premium at 82 dollars per hour, driven by longer trips averaging 66 dollars per fare. For drivers who can stay busy in Queens, particularly with airport runs, the per-hour return is higher.
+The bottom line is that each weather condition calls for a different strategy. Rain is an opportunity, snow rewards those who stay, and clear weather is about choosing between volume consistency in Manhattan or higher per-trip efficiency in Queens.</a:t>
             </a:r>
           </a:p>
         </p:txBody>
@@ -14894,7 +14894,59 @@
       </p:sp>
       <p:sp>
         <p:nvSpPr>
-          <p:cNvPr id="7" name="Rounded Rectangle 6"/>
+          <p:cNvPr id="8" name="Rounded Rectangle 7"/>
+          <p:cNvSpPr/>
+          <p:nvPr/>
+        </p:nvSpPr>
+        <p:spPr>
+          <a:xfrm>
+            <a:off x="400000" y="6000000"/>
+            <a:ext cx="11400000" cy="600000"/>
+          </a:xfrm>
+          <a:prstGeom prst="roundRect">
+            <a:avLst/>
+          </a:prstGeom>
+          <a:solidFill>
+            <a:srgbClr val="8B0138"/>
+          </a:solidFill>
+          <a:ln>
+            <a:noFill/>
+          </a:ln>
+        </p:spPr>
+        <p:style>
+          <a:lnRef idx="1">
+            <a:schemeClr val="accent1"/>
+          </a:lnRef>
+          <a:fillRef idx="3">
+            <a:schemeClr val="accent1"/>
+          </a:fillRef>
+          <a:effectRef idx="2">
+            <a:schemeClr val="accent1"/>
+          </a:effectRef>
+          <a:fontRef idx="minor">
+            <a:schemeClr val="lt1"/>
+          </a:fontRef>
+        </p:style>
+        <p:txBody>
+          <a:bodyPr rtlCol="0" anchor="ctr" lIns="200000" tIns="120000" rIns="180000" bIns="90000" wrap="square"/>
+          <a:lstStyle/>
+          <a:p>
+            <a:pPr algn="ctr"/>
+            <a:r>
+              <a:rPr sz="1300" b="1">
+                <a:solidFill>
+                  <a:srgbClr val="FFFFFF"/>
+                </a:solidFill>
+                <a:latin typeface="Trust Hartford Sans"/>
+              </a:rPr>
+              <a:t>Each weather condition calls for a different positioning strategy. Rain is an opportunity, snow rewards persistence, and clear weather is about volume consistency.</a:t>
+            </a:r>
+          </a:p>
+        </p:txBody>
+      </p:sp>
+      <p:sp>
+        <p:nvSpPr>
+          <p:cNvPr id="9" name="Rounded Rectangle 8"/>
           <p:cNvSpPr/>
           <p:nvPr/>
         </p:nvSpPr>
@@ -14939,13 +14991,13 @@
                 </a:solidFill>
                 <a:latin typeface="Trust Hartford Sans"/>
               </a:rPr>
-              <a:t>Clear Weather: Maximize Manhattan Volume</a:t>
+              <a:t>Clear Weather: Manhattan or Queens</a:t>
             </a:r>
           </a:p>
           <a:p>
             <a:pPr>
               <a:spcBef>
-                <a:spcPts val="1400"/>
+                <a:spcPts val="1200"/>
               </a:spcBef>
             </a:pPr>
             <a:r>
@@ -14955,13 +15007,13 @@
                 </a:solidFill>
                 <a:latin typeface="Trust Hartford Sans"/>
               </a:rPr>
-              <a:t>The Data</a:t>
+              <a:t>Manhattan: Volume</a:t>
             </a:r>
           </a:p>
           <a:p>
             <a:pPr>
               <a:spcBef>
-                <a:spcPts val="600"/>
+                <a:spcPts val="400"/>
               </a:spcBef>
             </a:pPr>
             <a:r>
@@ -14971,13 +15023,13 @@
                 </a:solidFill>
                 <a:latin typeface="Trust Hartford Sans"/>
               </a:rPr>
-              <a:t>4,539 trips/hr in Manhattan (10x any other borough)</a:t>
+              <a:t>4,539 trips/hr, $71/hr earnings</a:t>
             </a:r>
           </a:p>
           <a:p>
             <a:pPr>
               <a:spcBef>
-                <a:spcPts val="600"/>
+                <a:spcPts val="400"/>
               </a:spcBef>
             </a:pPr>
             <a:r>
@@ -14987,13 +15039,13 @@
                 </a:solidFill>
                 <a:latin typeface="Trust Hartford Sans"/>
               </a:rPr>
-              <a:t>Clear weather accounts for 94.5% of all operating hours</a:t>
+              <a:t>Minimal idle time between fares</a:t>
             </a:r>
           </a:p>
           <a:p>
             <a:pPr>
               <a:spcBef>
-                <a:spcPts val="1400"/>
+                <a:spcPts val="1200"/>
               </a:spcBef>
             </a:pPr>
             <a:r>
@@ -15003,13 +15055,13 @@
                 </a:solidFill>
                 <a:latin typeface="Trust Hartford Sans"/>
               </a:rPr>
-              <a:t>Why It Matters</a:t>
+              <a:t>Queens: Efficiency</a:t>
             </a:r>
           </a:p>
           <a:p>
             <a:pPr>
               <a:spcBef>
-                <a:spcPts val="600"/>
+                <a:spcPts val="400"/>
               </a:spcBef>
             </a:pPr>
             <a:r>
@@ -15019,59 +15071,55 @@
                 </a:solidFill>
                 <a:latin typeface="Trust Hartford Sans"/>
               </a:rPr>
-              <a:t>The majority of annual income is earned during clear conditions. Consistent volume minimizes downtime between fares.</a:t>
-            </a:r>
-          </a:p>
-        </p:txBody>
-      </p:sp>
-      <p:sp>
-        <p:nvSpPr>
-          <p:cNvPr id="8" name="Rounded Rectangle 7"/>
-          <p:cNvSpPr/>
-          <p:nvPr/>
-        </p:nvSpPr>
-        <p:spPr>
-          <a:xfrm>
-            <a:off x="400000" y="6000000"/>
-            <a:ext cx="11400000" cy="600000"/>
-          </a:xfrm>
-          <a:prstGeom prst="roundRect">
-            <a:avLst/>
-          </a:prstGeom>
-          <a:solidFill>
-            <a:srgbClr val="8B0138"/>
-          </a:solidFill>
-          <a:ln>
-            <a:noFill/>
-          </a:ln>
-        </p:spPr>
-        <p:style>
-          <a:lnRef idx="1">
-            <a:schemeClr val="accent1"/>
-          </a:lnRef>
-          <a:fillRef idx="3">
-            <a:schemeClr val="accent1"/>
-          </a:fillRef>
-          <a:effectRef idx="2">
-            <a:schemeClr val="accent1"/>
-          </a:effectRef>
-          <a:fontRef idx="minor">
-            <a:schemeClr val="lt1"/>
-          </a:fontRef>
-        </p:style>
-        <p:txBody>
-          <a:bodyPr rtlCol="0" anchor="ctr" lIns="200000" tIns="120000" rIns="180000" bIns="90000" wrap="square"/>
-          <a:lstStyle/>
-          <a:p>
-            <a:pPr algn="ctr"/>
-            <a:r>
-              <a:rPr sz="1300" b="1">
-                <a:solidFill>
-                  <a:srgbClr val="FFFFFF"/>
+              <a:t>$66 avg fare, $82/hr earnings (+15% over Manhattan)</a:t>
+            </a:r>
+          </a:p>
+          <a:p>
+            <a:pPr>
+              <a:spcBef>
+                <a:spcPts val="400"/>
+              </a:spcBef>
+            </a:pPr>
+            <a:r>
+              <a:rPr sz="1400" b="0">
+                <a:solidFill>
+                  <a:srgbClr val="E65100"/>
                 </a:solidFill>
                 <a:latin typeface="Trust Hartford Sans"/>
               </a:rPr>
-              <a:t>Each weather condition calls for a different positioning strategy. Rain is an opportunity, snow rewards persistence, and clear weather is about volume consistency.</a:t>
+              <a:t>Longer trips with higher per-minute return</a:t>
+            </a:r>
+          </a:p>
+          <a:p>
+            <a:pPr>
+              <a:spcBef>
+                <a:spcPts val="1200"/>
+              </a:spcBef>
+            </a:pPr>
+            <a:r>
+              <a:rPr sz="1400" b="1">
+                <a:solidFill>
+                  <a:srgbClr val="E65100"/>
+                </a:solidFill>
+                <a:latin typeface="Trust Hartford Sans"/>
+              </a:rPr>
+              <a:t>Why It Matters</a:t>
+            </a:r>
+          </a:p>
+          <a:p>
+            <a:pPr>
+              <a:spcBef>
+                <a:spcPts val="400"/>
+              </a:spcBef>
+            </a:pPr>
+            <a:r>
+              <a:rPr sz="1400" b="0">
+                <a:solidFill>
+                  <a:srgbClr val="E65100"/>
+                </a:solidFill>
+                <a:latin typeface="Trust Hartford Sans"/>
+              </a:rPr>
+              <a:t>Clear weather is 94.5% of all hours. Manhattan guarantees volume; Queens rewards drivers who stay busy with airport and cross-borough runs.</a:t>
             </a:r>
           </a:p>
         </p:txBody>

</xml_diff>

<commit_message>
Fix slide 17 numbers to match Streamlit fare definition
Uses (revenue - tips) / trips to exclude cash tip bias.
Queens: $58 avg fare, $73/hr. Manhattan: $22 avg fare, $64/hr.
Snow $/min changes: +8% to +29%. All numbers now consistent
with dashboard.
</commit_message>
<xml_diff>
--- a/docs/Capstone_Presentation (10).pptx
+++ b/docs/Capstone_Presentation (10).pptx
@@ -2201,8 +2201,8 @@
             <a:r>
               <a:t>ORLANDO: So what should taxi drivers actually do with this information? Our data supports three clear recommendations.
 First, when it rains, get to Brooklyn. Brooklyn is the only borough where both demand and earnings efficiency increase during rain. Demand surges 27 percent, from 188 to 238 trips per hour, and per-minute earnings rise 11 percent. No other borough shows that combination.
-Second, when it snows, stay on the road. This might sound counterintuitive because total trip volume drops during snow. But the drivers who remain available earn more per active minute of driving, in every single borough, ranging from 7 percent more in Manhattan to 29 percent more in the Bronx. In Manhattan specifically, that translates to roughly 76 dollars per hour versus 71 during clear weather. Fewer drivers on the road means less competition for the fares that are still available.
-Third, during clear weather, which accounts for 94.5 percent of all operating hours, drivers have two strong options. Manhattan offers unmatched volume at over 4,500 trips per hour, meaning minimal idle time between fares and consistent 71-dollar-per-hour earnings. Queens, on the other hand, offers a 15 percent earnings premium at 82 dollars per hour, driven by longer trips averaging 66 dollars per fare. For drivers who can stay busy in Queens, particularly with airport runs, the per-hour return is higher.
+Second, when it snows, stay on the road. This might sound counterintuitive because total trip volume drops during snow. But the drivers who remain available earn more per active minute of driving, in every single borough, ranging from 8 percent more in Manhattan to 29 percent more in the Bronx. In Manhattan specifically, that translates to roughly 69 dollars per hour versus 64 during clear weather. Fewer drivers on the road means less competition for the fares that are still available.
+Third, during clear weather, which accounts for 94.5 percent of all operating hours, drivers have two strong options. Manhattan offers unmatched volume at over 4,500 trips per hour, meaning minimal idle time between fares and consistent 64-dollar-per-hour earnings. Queens, on the other hand, offers a 14 percent earnings premium at 73 dollars per hour, driven by longer trips averaging 58 dollars per fare. For drivers who can stay busy in Queens, particularly with airport runs, the per-hour return is higher.
 The bottom line is that each weather condition calls for a different strategy. Rain is an opportunity, snow rewards those who stay, and clear weather is about choosing between volume consistency in Manhattan or higher per-trip efficiency in Queens.</a:t>
             </a:r>
           </a:p>
@@ -14723,7 +14723,7 @@
                 </a:solidFill>
                 <a:latin typeface="Trust Hartford Sans"/>
               </a:rPr>
-              <a:t>Per-minute earnings rise +11% ($1.16 → $1.29/min)</a:t>
+              <a:t>Per-minute earnings rise +11% ($1.14 → $1.26/min)</a:t>
             </a:r>
           </a:p>
           <a:p>
@@ -14839,7 +14839,7 @@
                 </a:solidFill>
                 <a:latin typeface="Trust Hartford Sans"/>
               </a:rPr>
-              <a:t>Earnings per active minute rise in every borough during snow (+7% to +29%)</a:t>
+              <a:t>Earnings per active minute rise in every borough during snow (+8% to +29%)</a:t>
             </a:r>
           </a:p>
           <a:p>
@@ -14855,7 +14855,7 @@
                 </a:solidFill>
                 <a:latin typeface="Trust Hartford Sans"/>
               </a:rPr>
-              <a:t>Manhattan snow: $76/hr vs $71/hr clear weather</a:t>
+              <a:t>Manhattan snow: $69/hr vs $64/hr clear weather</a:t>
             </a:r>
           </a:p>
           <a:p>
@@ -14888,6 +14888,186 @@
                 <a:latin typeface="Trust Hartford Sans"/>
               </a:rPr>
               <a:t>Drivers who remain available during snow face less competition and earn more per minute of driving time</a:t>
+            </a:r>
+          </a:p>
+        </p:txBody>
+      </p:sp>
+      <p:sp>
+        <p:nvSpPr>
+          <p:cNvPr id="7" name="Rounded Rectangle 6"/>
+          <p:cNvSpPr/>
+          <p:nvPr/>
+        </p:nvSpPr>
+        <p:spPr>
+          <a:xfrm>
+            <a:off x="8200000" y="1000000"/>
+            <a:ext cx="3600000" cy="4800000"/>
+          </a:xfrm>
+          <a:prstGeom prst="roundRect">
+            <a:avLst/>
+          </a:prstGeom>
+          <a:solidFill>
+            <a:srgbClr val="FFF3E0"/>
+          </a:solidFill>
+          <a:ln>
+            <a:noFill/>
+          </a:ln>
+        </p:spPr>
+        <p:style>
+          <a:lnRef idx="1">
+            <a:schemeClr val="accent1"/>
+          </a:lnRef>
+          <a:fillRef idx="3">
+            <a:schemeClr val="accent1"/>
+          </a:fillRef>
+          <a:effectRef idx="2">
+            <a:schemeClr val="accent1"/>
+          </a:effectRef>
+          <a:fontRef idx="minor">
+            <a:schemeClr val="lt1"/>
+          </a:fontRef>
+        </p:style>
+        <p:txBody>
+          <a:bodyPr rtlCol="0" anchor="ctr" lIns="180000" tIns="180000" rIns="180000" bIns="90000" wrap="square"/>
+          <a:lstStyle/>
+          <a:p>
+            <a:pPr algn="ctr"/>
+            <a:r>
+              <a:rPr sz="1600" b="1">
+                <a:solidFill>
+                  <a:srgbClr val="E65100"/>
+                </a:solidFill>
+                <a:latin typeface="Trust Hartford Sans"/>
+              </a:rPr>
+              <a:t>Clear Weather: Manhattan or Queens</a:t>
+            </a:r>
+          </a:p>
+          <a:p>
+            <a:pPr>
+              <a:spcBef>
+                <a:spcPts val="1200"/>
+              </a:spcBef>
+            </a:pPr>
+            <a:r>
+              <a:rPr sz="1400" b="1">
+                <a:solidFill>
+                  <a:srgbClr val="E65100"/>
+                </a:solidFill>
+                <a:latin typeface="Trust Hartford Sans"/>
+              </a:rPr>
+              <a:t>Manhattan: Volume</a:t>
+            </a:r>
+          </a:p>
+          <a:p>
+            <a:pPr>
+              <a:spcBef>
+                <a:spcPts val="400"/>
+              </a:spcBef>
+            </a:pPr>
+            <a:r>
+              <a:rPr sz="1400" b="0">
+                <a:solidFill>
+                  <a:srgbClr val="E65100"/>
+                </a:solidFill>
+                <a:latin typeface="Trust Hartford Sans"/>
+              </a:rPr>
+              <a:t>4,539 trips/hr, $64/hr earnings</a:t>
+            </a:r>
+          </a:p>
+          <a:p>
+            <a:pPr>
+              <a:spcBef>
+                <a:spcPts val="400"/>
+              </a:spcBef>
+            </a:pPr>
+            <a:r>
+              <a:rPr sz="1400" b="0">
+                <a:solidFill>
+                  <a:srgbClr val="E65100"/>
+                </a:solidFill>
+                <a:latin typeface="Trust Hartford Sans"/>
+              </a:rPr>
+              <a:t>Minimal idle time between fares</a:t>
+            </a:r>
+          </a:p>
+          <a:p>
+            <a:pPr>
+              <a:spcBef>
+                <a:spcPts val="1200"/>
+              </a:spcBef>
+            </a:pPr>
+            <a:r>
+              <a:rPr sz="1400" b="1">
+                <a:solidFill>
+                  <a:srgbClr val="E65100"/>
+                </a:solidFill>
+                <a:latin typeface="Trust Hartford Sans"/>
+              </a:rPr>
+              <a:t>Queens: Efficiency</a:t>
+            </a:r>
+          </a:p>
+          <a:p>
+            <a:pPr>
+              <a:spcBef>
+                <a:spcPts val="400"/>
+              </a:spcBef>
+            </a:pPr>
+            <a:r>
+              <a:rPr sz="1400" b="0">
+                <a:solidFill>
+                  <a:srgbClr val="E65100"/>
+                </a:solidFill>
+                <a:latin typeface="Trust Hartford Sans"/>
+              </a:rPr>
+              <a:t>$58 avg fare, $73/hr earnings (+14% over Manhattan)</a:t>
+            </a:r>
+          </a:p>
+          <a:p>
+            <a:pPr>
+              <a:spcBef>
+                <a:spcPts val="400"/>
+              </a:spcBef>
+            </a:pPr>
+            <a:r>
+              <a:rPr sz="1400" b="0">
+                <a:solidFill>
+                  <a:srgbClr val="E65100"/>
+                </a:solidFill>
+                <a:latin typeface="Trust Hartford Sans"/>
+              </a:rPr>
+              <a:t>Longer trips with higher per-minute return</a:t>
+            </a:r>
+          </a:p>
+          <a:p>
+            <a:pPr>
+              <a:spcBef>
+                <a:spcPts val="1200"/>
+              </a:spcBef>
+            </a:pPr>
+            <a:r>
+              <a:rPr sz="1400" b="1">
+                <a:solidFill>
+                  <a:srgbClr val="E65100"/>
+                </a:solidFill>
+                <a:latin typeface="Trust Hartford Sans"/>
+              </a:rPr>
+              <a:t>Why It Matters</a:t>
+            </a:r>
+          </a:p>
+          <a:p>
+            <a:pPr>
+              <a:spcBef>
+                <a:spcPts val="400"/>
+              </a:spcBef>
+            </a:pPr>
+            <a:r>
+              <a:rPr sz="1400" b="0">
+                <a:solidFill>
+                  <a:srgbClr val="E65100"/>
+                </a:solidFill>
+                <a:latin typeface="Trust Hartford Sans"/>
+              </a:rPr>
+              <a:t>94.5% of hours are clear. Manhattan guarantees volume; Queens rewards drivers who stay busy with airport and cross-borough runs.</a:t>
             </a:r>
           </a:p>
         </p:txBody>
@@ -14940,186 +15120,6 @@
                 <a:latin typeface="Trust Hartford Sans"/>
               </a:rPr>
               <a:t>Each weather condition calls for a different positioning strategy. Rain is an opportunity, snow rewards persistence, and clear weather is about volume consistency.</a:t>
-            </a:r>
-          </a:p>
-        </p:txBody>
-      </p:sp>
-      <p:sp>
-        <p:nvSpPr>
-          <p:cNvPr id="9" name="Rounded Rectangle 8"/>
-          <p:cNvSpPr/>
-          <p:nvPr/>
-        </p:nvSpPr>
-        <p:spPr>
-          <a:xfrm>
-            <a:off x="8200000" y="1000000"/>
-            <a:ext cx="3600000" cy="4800000"/>
-          </a:xfrm>
-          <a:prstGeom prst="roundRect">
-            <a:avLst/>
-          </a:prstGeom>
-          <a:solidFill>
-            <a:srgbClr val="FFF3E0"/>
-          </a:solidFill>
-          <a:ln>
-            <a:noFill/>
-          </a:ln>
-        </p:spPr>
-        <p:style>
-          <a:lnRef idx="1">
-            <a:schemeClr val="accent1"/>
-          </a:lnRef>
-          <a:fillRef idx="3">
-            <a:schemeClr val="accent1"/>
-          </a:fillRef>
-          <a:effectRef idx="2">
-            <a:schemeClr val="accent1"/>
-          </a:effectRef>
-          <a:fontRef idx="minor">
-            <a:schemeClr val="lt1"/>
-          </a:fontRef>
-        </p:style>
-        <p:txBody>
-          <a:bodyPr rtlCol="0" anchor="ctr" lIns="180000" tIns="180000" rIns="180000" bIns="90000" wrap="square"/>
-          <a:lstStyle/>
-          <a:p>
-            <a:pPr algn="ctr"/>
-            <a:r>
-              <a:rPr sz="1600" b="1">
-                <a:solidFill>
-                  <a:srgbClr val="E65100"/>
-                </a:solidFill>
-                <a:latin typeface="Trust Hartford Sans"/>
-              </a:rPr>
-              <a:t>Clear Weather: Manhattan or Queens</a:t>
-            </a:r>
-          </a:p>
-          <a:p>
-            <a:pPr>
-              <a:spcBef>
-                <a:spcPts val="1200"/>
-              </a:spcBef>
-            </a:pPr>
-            <a:r>
-              <a:rPr sz="1400" b="1">
-                <a:solidFill>
-                  <a:srgbClr val="E65100"/>
-                </a:solidFill>
-                <a:latin typeface="Trust Hartford Sans"/>
-              </a:rPr>
-              <a:t>Manhattan: Volume</a:t>
-            </a:r>
-          </a:p>
-          <a:p>
-            <a:pPr>
-              <a:spcBef>
-                <a:spcPts val="400"/>
-              </a:spcBef>
-            </a:pPr>
-            <a:r>
-              <a:rPr sz="1400" b="0">
-                <a:solidFill>
-                  <a:srgbClr val="E65100"/>
-                </a:solidFill>
-                <a:latin typeface="Trust Hartford Sans"/>
-              </a:rPr>
-              <a:t>4,539 trips/hr, $71/hr earnings</a:t>
-            </a:r>
-          </a:p>
-          <a:p>
-            <a:pPr>
-              <a:spcBef>
-                <a:spcPts val="400"/>
-              </a:spcBef>
-            </a:pPr>
-            <a:r>
-              <a:rPr sz="1400" b="0">
-                <a:solidFill>
-                  <a:srgbClr val="E65100"/>
-                </a:solidFill>
-                <a:latin typeface="Trust Hartford Sans"/>
-              </a:rPr>
-              <a:t>Minimal idle time between fares</a:t>
-            </a:r>
-          </a:p>
-          <a:p>
-            <a:pPr>
-              <a:spcBef>
-                <a:spcPts val="1200"/>
-              </a:spcBef>
-            </a:pPr>
-            <a:r>
-              <a:rPr sz="1400" b="1">
-                <a:solidFill>
-                  <a:srgbClr val="E65100"/>
-                </a:solidFill>
-                <a:latin typeface="Trust Hartford Sans"/>
-              </a:rPr>
-              <a:t>Queens: Efficiency</a:t>
-            </a:r>
-          </a:p>
-          <a:p>
-            <a:pPr>
-              <a:spcBef>
-                <a:spcPts val="400"/>
-              </a:spcBef>
-            </a:pPr>
-            <a:r>
-              <a:rPr sz="1400" b="0">
-                <a:solidFill>
-                  <a:srgbClr val="E65100"/>
-                </a:solidFill>
-                <a:latin typeface="Trust Hartford Sans"/>
-              </a:rPr>
-              <a:t>$66 avg fare, $82/hr earnings (+15% over Manhattan)</a:t>
-            </a:r>
-          </a:p>
-          <a:p>
-            <a:pPr>
-              <a:spcBef>
-                <a:spcPts val="400"/>
-              </a:spcBef>
-            </a:pPr>
-            <a:r>
-              <a:rPr sz="1400" b="0">
-                <a:solidFill>
-                  <a:srgbClr val="E65100"/>
-                </a:solidFill>
-                <a:latin typeface="Trust Hartford Sans"/>
-              </a:rPr>
-              <a:t>Longer trips with higher per-minute return</a:t>
-            </a:r>
-          </a:p>
-          <a:p>
-            <a:pPr>
-              <a:spcBef>
-                <a:spcPts val="1200"/>
-              </a:spcBef>
-            </a:pPr>
-            <a:r>
-              <a:rPr sz="1400" b="1">
-                <a:solidFill>
-                  <a:srgbClr val="E65100"/>
-                </a:solidFill>
-                <a:latin typeface="Trust Hartford Sans"/>
-              </a:rPr>
-              <a:t>Why It Matters</a:t>
-            </a:r>
-          </a:p>
-          <a:p>
-            <a:pPr>
-              <a:spcBef>
-                <a:spcPts val="400"/>
-              </a:spcBef>
-            </a:pPr>
-            <a:r>
-              <a:rPr sz="1400" b="0">
-                <a:solidFill>
-                  <a:srgbClr val="E65100"/>
-                </a:solidFill>
-                <a:latin typeface="Trust Hartford Sans"/>
-              </a:rPr>
-              <a:t>Clear weather is 94.5% of all hours. Manhattan guarantees volume; Queens rewards drivers who stay busy with airport and cross-borough runs.</a:t>
             </a:r>
           </a:p>
         </p:txBody>

</xml_diff>

<commit_message>
Slide 17: use $/min throughout, remove utilization assumption
All earnings figures now show revenue per active minute (fare excluding
tips divided by trip duration). No assumptions required. Consistent
with Streamlit dashboard calculations.
</commit_message>
<xml_diff>
--- a/docs/Capstone_Presentation (10).pptx
+++ b/docs/Capstone_Presentation (10).pptx
@@ -2200,9 +2200,10 @@
           <a:p>
             <a:r>
               <a:t>ORLANDO: So what should taxi drivers actually do with this information? Our data supports three clear recommendations.
-First, when it rains, get to Brooklyn. Brooklyn is the only borough where both demand and earnings efficiency increase during rain. Demand surges 27 percent, from 188 to 238 trips per hour, and per-minute earnings rise 11 percent. No other borough shows that combination.
-Second, when it snows, stay on the road. This might sound counterintuitive because total trip volume drops during snow. But the drivers who remain available earn more per active minute of driving, in every single borough, ranging from 8 percent more in Manhattan to 29 percent more in the Bronx. In Manhattan specifically, that translates to roughly 69 dollars per hour versus 64 during clear weather. Fewer drivers on the road means less competition for the fares that are still available.
-Third, during clear weather, which accounts for 94.5 percent of all operating hours, drivers have two strong options. Manhattan offers unmatched volume at over 4,500 trips per hour, meaning minimal idle time between fares and consistent 64-dollar-per-hour earnings. Queens, on the other hand, offers a 14 percent earnings premium at 73 dollars per hour, driven by longer trips averaging 58 dollars per fare. For drivers who can stay busy in Queens, particularly with airport runs, the per-hour return is higher.
+First, when it rains, get to Brooklyn. Brooklyn is the only borough where both demand and earnings efficiency increase during rain. Demand surges 27 percent, from 188 to 238 trips per hour, and per-minute earnings rise 11 percent, from $1.14 to $1.26 per active minute. No other borough shows that combination.
+Second, when it snows, stay on the road. This might sound counterintuitive because total trip volume drops during snow. But the drivers who remain available earn more per active minute of driving, in every single borough, ranging from 8 percent more in Manhattan to 29 percent more in the Bronx. In Manhattan, that's $1.52 per minute during clear weather rising to $1.64 during snow. Fewer drivers on the road means less competition for the fares that are still available.
+Third, during clear weather, which accounts for 94.5 percent of all operating hours, drivers have two strong options. Manhattan offers unmatched volume at over 4,500 trips per hour, meaning minimal idle time between fares, at $1.52 per active minute. Queens offers a 14 percent earnings premium at $1.73 per active minute, driven by longer trips averaging $58 per fare. For drivers who can stay busy in Queens, particularly with airport runs, the per-minute return is higher.
+All of these figures exclude tips to avoid the cash tip recording bias in the data. They represent fare revenue earned per minute of active driving time.
 The bottom line is that each weather condition calls for a different strategy. Rain is an opportunity, snow rewards those who stay, and clear weather is about choosing between volume consistency in Manhattan or higher per-trip efficiency in Queens.</a:t>
             </a:r>
           </a:p>
@@ -14855,7 +14856,7 @@
                 </a:solidFill>
                 <a:latin typeface="Trust Hartford Sans"/>
               </a:rPr>
-              <a:t>Manhattan snow: $69/hr vs $64/hr clear weather</a:t>
+              <a:t>Manhattan: $1.52/min clear → $1.64/min snow (+8%)</a:t>
             </a:r>
           </a:p>
           <a:p>
@@ -14971,7 +14972,7 @@
                 </a:solidFill>
                 <a:latin typeface="Trust Hartford Sans"/>
               </a:rPr>
-              <a:t>4,539 trips/hr, $64/hr earnings</a:t>
+              <a:t>4,539 trips/hr, $1.52/min earnings</a:t>
             </a:r>
           </a:p>
           <a:p>
@@ -15019,7 +15020,7 @@
                 </a:solidFill>
                 <a:latin typeface="Trust Hartford Sans"/>
               </a:rPr>
-              <a:t>$58 avg fare, $73/hr earnings (+14% over Manhattan)</a:t>
+              <a:t>$58 avg fare, $1.73/min earnings (+14% over Manhattan)</a:t>
             </a:r>
           </a:p>
           <a:p>

</xml_diff>

<commit_message>
Update Future State slide: replace multi-city with expanded analysis
Third card now proposes full-year seasonality study and rideshare
(Uber/Lyft) surge pricing comparison instead of multi-city expansion.
Speaker notes updated minimally for the new third point.
</commit_message>
<xml_diff>
--- a/docs/Capstone_Presentation (10).pptx
+++ b/docs/Capstone_Presentation (10).pptx
@@ -2356,72 +2356,12 @@
           <a:lstStyle/>
           <a:p>
             <a:r>
-              <a:rPr lang="en-US"/>
-              <a:t>We identified three potential next steps to build on this solution.</a:t>
-            </a:r>
-          </a:p>
-          <a:p>
-            <a:endParaRPr lang="en-US"/>
-          </a:p>
-          <a:p>
-            <a:r>
-              <a:rPr lang="en-US"/>
-              <a:t>First, </a:t>
-            </a:r>
-            <a:r>
-              <a:rPr lang="en-US" b="1"/>
-              <a:t>real-time ingestion</a:t>
-            </a:r>
-            <a:r>
-              <a:rPr lang="en-US"/>
-              <a:t> would allow trip and weather data to flow continuously, giving operators a more up-to-date view of demand during storms.</a:t>
-            </a:r>
-          </a:p>
-          <a:p>
-            <a:endParaRPr lang="en-US"/>
-          </a:p>
-          <a:p>
-            <a:r>
-              <a:rPr lang="en-US"/>
-              <a:t>Second, </a:t>
-            </a:r>
-            <a:r>
-              <a:rPr lang="en-US" b="1"/>
-              <a:t>machine learning forecasting</a:t>
-            </a:r>
-            <a:r>
-              <a:rPr lang="en-US"/>
-              <a:t> could help predict demand changes before weather events occur, enabling more proactive planning.</a:t>
-            </a:r>
-          </a:p>
-          <a:p>
-            <a:endParaRPr lang="en-US"/>
-          </a:p>
-          <a:p>
-            <a:r>
-              <a:rPr lang="en-US"/>
-              <a:t>Third, as our current solution is </a:t>
-            </a:r>
-            <a:r>
-              <a:rPr lang="en-US" b="1"/>
-              <a:t>scalable, it </a:t>
-            </a:r>
-            <a:r>
-              <a:rPr lang="en-US"/>
-              <a:t>could be expanded to other cities with similar taxi and weather data.</a:t>
-            </a:r>
-          </a:p>
-          <a:p>
-            <a:endParaRPr lang="en-US"/>
-          </a:p>
-          <a:p>
-            <a:r>
-              <a:rPr lang="en-US" b="1"/>
-              <a:t>Our top recommendation is real-time ingestion because it offers the greatest business value with the lowest implementation effort.</a:t>
-            </a:r>
-          </a:p>
-          <a:p>
-            <a:endParaRPr/>
+              <a:t>We identified three potential next steps to build on this solution.
+First, real-time ingestion would allow trip and weather data to flow continuously, giving operators a more up-to-date view of demand during storms.
+Second, machine learning forecasting could help predict demand changes before weather events occur, enabling more proactive planning.
+Third, we would expand the analysis itself. Our current dataset covers January through May, so we're missing summer and fall seasonality. A full year of data would reveal whether these patterns hold across all seasons. We'd also incorporate rideshare data from Uber and Lyft to understand how surge pricing during adverse weather competes with traditional taxi demand.
+Our top recommendation is real-time ingestion because it offers the greatest business value with the lowest implementation effort.</a:t>
+            </a:r>
           </a:p>
         </p:txBody>
       </p:sp>
@@ -15611,152 +15551,6 @@
       </p:sp>
       <p:sp>
         <p:nvSpPr>
-          <p:cNvPr id="7" name="Rounded Rectangle 6"/>
-          <p:cNvSpPr/>
-          <p:nvPr/>
-        </p:nvSpPr>
-        <p:spPr>
-          <a:xfrm>
-            <a:off x="8200000" y="1000000"/>
-            <a:ext cx="3600000" cy="4800000"/>
-          </a:xfrm>
-          <a:prstGeom prst="roundRect">
-            <a:avLst/>
-          </a:prstGeom>
-          <a:solidFill>
-            <a:srgbClr val="FFF3E0"/>
-          </a:solidFill>
-          <a:ln>
-            <a:noFill/>
-          </a:ln>
-        </p:spPr>
-        <p:style>
-          <a:lnRef idx="1">
-            <a:schemeClr val="accent1"/>
-          </a:lnRef>
-          <a:fillRef idx="3">
-            <a:schemeClr val="accent1"/>
-          </a:fillRef>
-          <a:effectRef idx="2">
-            <a:schemeClr val="accent1"/>
-          </a:effectRef>
-          <a:fontRef idx="minor">
-            <a:schemeClr val="lt1"/>
-          </a:fontRef>
-        </p:style>
-        <p:txBody>
-          <a:bodyPr wrap="square" lIns="91440" tIns="45720" rIns="91440" bIns="45720" rtlCol="0" anchor="ctr"/>
-          <a:lstStyle/>
-          <a:p>
-            <a:pPr algn="ctr">
-              <a:lnSpc>
-                <a:spcPct val="150000"/>
-              </a:lnSpc>
-            </a:pPr>
-            <a:r>
-              <a:rPr lang="en-US" sz="1600" b="1">
-                <a:solidFill>
-                  <a:schemeClr val="accent1">
-                    <a:lumMod val="76000"/>
-                  </a:schemeClr>
-                </a:solidFill>
-              </a:rPr>
-              <a:t>Multi-City Expansion</a:t>
-            </a:r>
-            <a:endParaRPr lang="en-US"/>
-          </a:p>
-          <a:p>
-            <a:pPr algn="ctr">
-              <a:lnSpc>
-                <a:spcPct val="150000"/>
-              </a:lnSpc>
-              <a:spcBef>
-                <a:spcPts val="1600"/>
-              </a:spcBef>
-            </a:pPr>
-            <a:r>
-              <a:rPr lang="en-US" sz="1400" b="1">
-                <a:solidFill>
-                  <a:schemeClr val="accent1">
-                    <a:lumMod val="76000"/>
-                  </a:schemeClr>
-                </a:solidFill>
-              </a:rPr>
-              <a:t>What We Would Do</a:t>
-            </a:r>
-          </a:p>
-          <a:p>
-            <a:pPr algn="ctr">
-              <a:lnSpc>
-                <a:spcPct val="150000"/>
-              </a:lnSpc>
-            </a:pPr>
-            <a:r>
-              <a:rPr lang="en-US" sz="1400">
-                <a:solidFill>
-                  <a:schemeClr val="accent1">
-                    <a:lumMod val="76000"/>
-                  </a:schemeClr>
-                </a:solidFill>
-              </a:rPr>
-              <a:t>Extend the solution to additional cities</a:t>
-            </a:r>
-          </a:p>
-          <a:p>
-            <a:pPr algn="ctr">
-              <a:lnSpc>
-                <a:spcPct val="150000"/>
-              </a:lnSpc>
-            </a:pPr>
-            <a:endParaRPr lang="en-US" sz="1400">
-              <a:solidFill>
-                <a:schemeClr val="accent1">
-                  <a:lumMod val="76000"/>
-                </a:schemeClr>
-              </a:solidFill>
-            </a:endParaRPr>
-          </a:p>
-          <a:p>
-            <a:pPr algn="ctr">
-              <a:lnSpc>
-                <a:spcPct val="150000"/>
-              </a:lnSpc>
-              <a:spcBef>
-                <a:spcPts val="1200"/>
-              </a:spcBef>
-            </a:pPr>
-            <a:r>
-              <a:rPr lang="en-US" sz="1400" b="1">
-                <a:solidFill>
-                  <a:schemeClr val="accent1">
-                    <a:lumMod val="76000"/>
-                  </a:schemeClr>
-                </a:solidFill>
-              </a:rPr>
-              <a:t>Business Benefit</a:t>
-            </a:r>
-          </a:p>
-          <a:p>
-            <a:pPr algn="ctr">
-              <a:lnSpc>
-                <a:spcPct val="150000"/>
-              </a:lnSpc>
-            </a:pPr>
-            <a:r>
-              <a:rPr lang="en-US" sz="1400">
-                <a:solidFill>
-                  <a:schemeClr val="accent1">
-                    <a:lumMod val="76000"/>
-                  </a:schemeClr>
-                </a:solidFill>
-              </a:rPr>
-              <a:t>Enable broader demand and weather insights across markets</a:t>
-            </a:r>
-          </a:p>
-        </p:txBody>
-      </p:sp>
-      <p:sp>
-        <p:nvSpPr>
           <p:cNvPr id="8" name="Rounded Rectangle 7"/>
           <p:cNvSpPr/>
           <p:nvPr/>
@@ -15808,6 +15602,136 @@
                 <a:srgbClr val="8B0138"/>
               </a:solidFill>
             </a:endParaRPr>
+          </a:p>
+        </p:txBody>
+      </p:sp>
+      <p:sp>
+        <p:nvSpPr>
+          <p:cNvPr id="9" name="Rounded Rectangle 8"/>
+          <p:cNvSpPr/>
+          <p:nvPr/>
+        </p:nvSpPr>
+        <p:spPr>
+          <a:xfrm>
+            <a:off x="8200000" y="1000000"/>
+            <a:ext cx="3600000" cy="4800000"/>
+          </a:xfrm>
+          <a:prstGeom prst="roundRect">
+            <a:avLst/>
+          </a:prstGeom>
+          <a:noFill/>
+          <a:ln>
+            <a:noFill/>
+          </a:ln>
+        </p:spPr>
+        <p:style>
+          <a:lnRef idx="1">
+            <a:schemeClr val="accent1"/>
+          </a:lnRef>
+          <a:fillRef idx="3">
+            <a:schemeClr val="accent1"/>
+          </a:fillRef>
+          <a:effectRef idx="2">
+            <a:schemeClr val="accent1"/>
+          </a:effectRef>
+          <a:fontRef idx="minor">
+            <a:schemeClr val="lt1"/>
+          </a:fontRef>
+        </p:style>
+        <p:txBody>
+          <a:bodyPr rtlCol="0" anchor="ctr" lIns="180000" tIns="180000" rIns="180000" bIns="90000" wrap="square"/>
+          <a:lstStyle/>
+          <a:p>
+            <a:pPr algn="ctr"/>
+            <a:r>
+              <a:rPr sz="1600" b="1">
+                <a:solidFill>
+                  <a:srgbClr val="E65100"/>
+                </a:solidFill>
+                <a:latin typeface="Trust Hartford Sans"/>
+              </a:rPr>
+              <a:t>Expanded Analysis</a:t>
+            </a:r>
+          </a:p>
+          <a:p>
+            <a:pPr>
+              <a:spcBef>
+                <a:spcPts val="1000"/>
+              </a:spcBef>
+            </a:pPr>
+            <a:r>
+              <a:rPr sz="1400" b="1">
+                <a:solidFill>
+                  <a:srgbClr val="E65100"/>
+                </a:solidFill>
+                <a:latin typeface="Trust Hartford Sans"/>
+              </a:rPr>
+              <a:t>What We Would Do</a:t>
+            </a:r>
+          </a:p>
+          <a:p>
+            <a:pPr>
+              <a:spcBef>
+                <a:spcPts val="600"/>
+              </a:spcBef>
+            </a:pPr>
+            <a:r>
+              <a:rPr sz="1400" b="0">
+                <a:solidFill>
+                  <a:srgbClr val="E65100"/>
+                </a:solidFill>
+                <a:latin typeface="Trust Hartford Sans"/>
+              </a:rPr>
+              <a:t>Extend to full-year data to capture seasonality (summer vs winter demand patterns)</a:t>
+            </a:r>
+          </a:p>
+          <a:p>
+            <a:pPr>
+              <a:spcBef>
+                <a:spcPts val="600"/>
+              </a:spcBef>
+            </a:pPr>
+            <a:r>
+              <a:rPr sz="1400" b="0">
+                <a:solidFill>
+                  <a:srgbClr val="E65100"/>
+                </a:solidFill>
+                <a:latin typeface="Trust Hartford Sans"/>
+              </a:rPr>
+              <a:t>Incorporate rideshare data (Uber, Lyft) to compare surge pricing behavior during adverse weather</a:t>
+            </a:r>
+          </a:p>
+          <a:p>
+            <a:pPr>
+              <a:spcBef>
+                <a:spcPts val="1000"/>
+              </a:spcBef>
+            </a:pPr>
+            <a:r>
+              <a:rPr sz="1400" b="1">
+                <a:solidFill>
+                  <a:srgbClr val="E65100"/>
+                </a:solidFill>
+                <a:latin typeface="Trust Hartford Sans"/>
+              </a:rPr>
+              <a:t>Business Benefit</a:t>
+            </a:r>
+          </a:p>
+          <a:p>
+            <a:pPr>
+              <a:spcBef>
+                <a:spcPts val="600"/>
+              </a:spcBef>
+            </a:pPr>
+            <a:r>
+              <a:rPr sz="1400" b="0">
+                <a:solidFill>
+                  <a:srgbClr val="E65100"/>
+                </a:solidFill>
+                <a:latin typeface="Trust Hartford Sans"/>
+              </a:rPr>
+              <a:t>Understand whether weather impacts differ across seasons and how surge pricing competes with taxi demand during storms</a:t>
+            </a:r>
           </a:p>
         </p:txBody>
       </p:sp>

</xml_diff>

<commit_message>
Trim Expanded Analysis card and fix whether/weather phrasing
</commit_message>
<xml_diff>
--- a/docs/Capstone_Presentation (10).pptx
+++ b/docs/Capstone_Presentation (10).pptx
@@ -2358,8 +2358,8 @@
             <a:r>
               <a:t>We identified three potential next steps to build on this solution.
 First, real-time ingestion would allow trip and weather data to flow continuously, giving operators a more up-to-date view of demand during storms.
-Second, machine learning forecasting could help predict demand changes before weather events occur, enabling more proactive planning.
-Third, we would expand the analysis itself. Our current dataset covers January through May, so we're missing summer and fall seasonality. A full year of data would reveal whether these patterns hold across all seasons. We'd also incorporate rideshare data from Uber and Lyft to understand how surge pricing during adverse weather competes with traditional taxi demand.
+Second, machine learning forecasting could help predict demand changes before storms occur, enabling more proactive planning.
+Third, we would expand the analysis itself. Our current dataset covers January through May, so we're missing summer and fall seasonality. A full year of data would show how these patterns hold across all seasons. We'd also incorporate rideshare data from Uber and Lyft to understand how surge pricing during storms competes with traditional taxi demand.
 Our top recommendation is real-time ingestion because it offers the greatest business value with the lowest implementation effort.</a:t>
             </a:r>
           </a:p>
@@ -15682,7 +15682,7 @@
                 </a:solidFill>
                 <a:latin typeface="Trust Hartford Sans"/>
               </a:rPr>
-              <a:t>Extend to full-year data to capture seasonality (summer vs winter demand patterns)</a:t>
+              <a:t>Extend to full-year data for seasonal patterns</a:t>
             </a:r>
           </a:p>
           <a:p>
@@ -15698,7 +15698,7 @@
                 </a:solidFill>
                 <a:latin typeface="Trust Hartford Sans"/>
               </a:rPr>
-              <a:t>Incorporate rideshare data (Uber, Lyft) to compare surge pricing behavior during adverse weather</a:t>
+              <a:t>Incorporate Uber/Lyft to compare surge pricing during storms</a:t>
             </a:r>
           </a:p>
           <a:p>
@@ -15730,7 +15730,7 @@
                 </a:solidFill>
                 <a:latin typeface="Trust Hartford Sans"/>
               </a:rPr>
-              <a:t>Understand whether weather impacts differ across seasons and how surge pricing competes with taxi demand during storms</a:t>
+              <a:t>Reveal how demand shifts across all seasons and how rideshare surge pricing competes with taxis</a:t>
             </a:r>
           </a:p>
         </p:txBody>

</xml_diff>

<commit_message>
Update headline finding (slide 5) and AI disclosure (slide 21)
Slide 5: new headline emphasizing per-minute earnings insight,
updated business insight with weather-specific driver strategies.

Slide 21: filled in AI disclosure with Claude Code usage across
pipeline, Streamlit, and presentation work. Includes corrections
section documenting what was caught and fixed.
</commit_message>
<xml_diff>
--- a/docs/Capstone_Presentation (10).pptx
+++ b/docs/Capstone_Presentation (10).pptx
@@ -2745,27 +2745,15 @@
           <a:lstStyle/>
           <a:p>
             <a:r>
-              <a:rPr lang="en-US">
-                <a:solidFill>
-                  <a:srgbClr val="555555"/>
-                </a:solidFill>
-              </a:rPr>
-              <a:t>ORLANDO: We'll start with the main insight from our analysis. In 2025, bad weather actually helped taxi operators. In 2026, that relationship reversed, particularly during snow events that were far more severe than the year before. Most importantly is when the storm hits. A single storm-hour during rush hour in Manhattan now represents over $43K per hour in lost revenue compared to a clear-weather hour. For taxi operators, the takeaway is that it's crucial to plan around when adverse weather is coming and have drivers on the road during those high impact windows like rush hour.</a:t>
+              <a:t>ORLANDO: Here's the headline from our analysis. We found that adverse weather doesn't reduce what a ride costs. It reduces how many rides happen. But for the drivers who stay on the road, they actually earn more per minute of active driving time.
+We analyzed over 38 million trips across 10 months and all five boroughs. The key insight is that each weather condition calls for a different positioning strategy.
+During rain, Brooklyn is the clear winner: demand surges 27 percent and per-minute earnings rise 11 percent. During snow, earnings per active minute rise in every borough, from 8 percent in Manhattan to 29 percent in the Bronx. And during clear weather, which is 94.5 percent of all hours, drivers choose between Manhattan's unmatched volume or Queens' 14 percent per-minute premium on longer trips.
+The bottom line: weather creates positioning opportunities, not just risk.</a:t>
             </a:r>
             <a:endParaRPr lang="en-US">
               <a:solidFill>
                 <a:srgbClr val="000000"/>
               </a:solidFill>
-            </a:endParaRPr>
-          </a:p>
-          <a:p>
-            <a:pPr algn="ctr"/>
-            <a:endParaRPr lang="en-US" i="1">
-              <a:solidFill>
-                <a:srgbClr val="555555"/>
-              </a:solidFill>
-              <a:ea typeface="Calibri"/>
-              <a:cs typeface="Calibri"/>
             </a:endParaRPr>
           </a:p>
         </p:txBody>
@@ -16255,7 +16243,7 @@
             <a:avLst/>
           </a:prstGeom>
           <a:solidFill>
-            <a:srgbClr val="1A237E"/>
+            <a:srgbClr val="0D47A1"/>
           </a:solidFill>
           <a:ln>
             <a:noFill/>
@@ -16276,17 +16264,18 @@
           </a:fontRef>
         </p:style>
         <p:txBody>
-          <a:bodyPr wrap="square" rtlCol="0" anchor="ctr"/>
+          <a:bodyPr rtlCol="0" anchor="ctr" lIns="180000" tIns="180000" rIns="180000" bIns="90000" wrap="square"/>
           <a:lstStyle/>
           <a:p>
             <a:pPr algn="ctr"/>
             <a:r>
-              <a:rPr sz="1300" b="1">
+              <a:rPr sz="1200" b="1">
                 <a:solidFill>
                   <a:srgbClr val="FFFFFF"/>
                 </a:solidFill>
-              </a:rPr>
-              <a:t>  Where We Used AI                    What For                              What We Verified</a:t>
+                <a:latin typeface="Trust Hartford Sans"/>
+              </a:rPr>
+              <a:t>Where We Used AI                    What For                                        How We Verified</a:t>
             </a:r>
           </a:p>
         </p:txBody>
@@ -16300,7 +16289,7 @@
         <p:spPr>
           <a:xfrm>
             <a:off x="400000" y="1650000"/>
-            <a:ext cx="11400000" cy="500000"/>
+            <a:ext cx="11400000" cy="550000"/>
           </a:xfrm>
           <a:prstGeom prst="roundRect">
             <a:avLst/>
@@ -16327,17 +16316,29 @@
           </a:fontRef>
         </p:style>
         <p:txBody>
-          <a:bodyPr wrap="square" rtlCol="0" anchor="ctr"/>
+          <a:bodyPr rtlCol="0" anchor="ctr" lIns="180000" tIns="180000" rIns="180000" bIns="90000" wrap="square"/>
           <a:lstStyle/>
           <a:p>
             <a:pPr algn="ctr"/>
             <a:r>
-              <a:rPr sz="1200">
+              <a:rPr sz="1102" b="0">
                 <a:solidFill>
                   <a:srgbClr val="2D2D2D"/>
                 </a:solidFill>
-              </a:rPr>
-              <a:t>  [Tool]                                        [Purpose]                                    [Verification]</a:t>
+                <a:latin typeface="Trust Hartford Sans"/>
+              </a:rPr>
+              <a:t>Claude Code                         Pipeline orchestration, dbt models,       Ran full pipeline end-to-end, verified</a:t>
+            </a:r>
+          </a:p>
+          <a:p>
+            <a:r>
+              <a:rPr sz="1102" b="0">
+                <a:solidFill>
+                  <a:srgbClr val="2D2D2D"/>
+                </a:solidFill>
+                <a:latin typeface="Trust Hartford Sans"/>
+              </a:rPr>
+              <a:t>                                           SQL transformations                              row counts against source files</a:t>
             </a:r>
           </a:p>
         </p:txBody>
@@ -16350,15 +16351,13 @@
         </p:nvSpPr>
         <p:spPr>
           <a:xfrm>
-            <a:off x="400000" y="2200000"/>
-            <a:ext cx="11400000" cy="500000"/>
+            <a:off x="400000" y="2250000"/>
+            <a:ext cx="11400000" cy="550000"/>
           </a:xfrm>
           <a:prstGeom prst="roundRect">
             <a:avLst/>
           </a:prstGeom>
-          <a:solidFill>
-            <a:srgbClr val="F0F7FF"/>
-          </a:solidFill>
+          <a:noFill/>
           <a:ln>
             <a:noFill/>
           </a:ln>
@@ -16378,17 +16377,29 @@
           </a:fontRef>
         </p:style>
         <p:txBody>
-          <a:bodyPr wrap="square" rtlCol="0" anchor="ctr"/>
+          <a:bodyPr rtlCol="0" anchor="ctr" lIns="180000" tIns="180000" rIns="180000" bIns="90000" wrap="square"/>
           <a:lstStyle/>
           <a:p>
             <a:pPr algn="ctr"/>
             <a:r>
-              <a:rPr sz="1200">
+              <a:rPr sz="1102" b="0">
                 <a:solidFill>
                   <a:srgbClr val="2D2D2D"/>
                 </a:solidFill>
-              </a:rPr>
-              <a:t>  [Tool]                                        [Purpose]                                    [Verification]</a:t>
+                <a:latin typeface="Trust Hartford Sans"/>
+              </a:rPr>
+              <a:t>Claude Code                         Streamlit visualizations, chart            Validated all calculations against</a:t>
+            </a:r>
+          </a:p>
+          <a:p>
+            <a:r>
+              <a:rPr sz="1102" b="0">
+                <a:solidFill>
+                  <a:srgbClr val="2D2D2D"/>
+                </a:solidFill>
+                <a:latin typeface="Trust Hartford Sans"/>
+              </a:rPr>
+              <a:t>                                           logic, data analysis                                 raw data and Tableau results</a:t>
             </a:r>
           </a:p>
         </p:txBody>
@@ -16401,8 +16412,8 @@
         </p:nvSpPr>
         <p:spPr>
           <a:xfrm>
-            <a:off x="400000" y="2750000"/>
-            <a:ext cx="11400000" cy="500000"/>
+            <a:off x="400000" y="2850000"/>
+            <a:ext cx="11400000" cy="550000"/>
           </a:xfrm>
           <a:prstGeom prst="roundRect">
             <a:avLst/>
@@ -16429,17 +16440,29 @@
           </a:fontRef>
         </p:style>
         <p:txBody>
-          <a:bodyPr wrap="square" rtlCol="0" anchor="ctr"/>
+          <a:bodyPr rtlCol="0" anchor="ctr" lIns="180000" tIns="180000" rIns="180000" bIns="90000" wrap="square"/>
           <a:lstStyle/>
           <a:p>
             <a:pPr algn="ctr"/>
             <a:r>
-              <a:rPr sz="1200">
+              <a:rPr sz="1102" b="0">
                 <a:solidFill>
                   <a:srgbClr val="2D2D2D"/>
                 </a:solidFill>
-              </a:rPr>
-              <a:t>  [Tool]                                        [Purpose]                                    [Verification]</a:t>
+                <a:latin typeface="Trust Hartford Sans"/>
+              </a:rPr>
+              <a:t>Claude Code                         Slide content drafting, speaker             Rewrote and revised all content;</a:t>
+            </a:r>
+          </a:p>
+          <a:p>
+            <a:r>
+              <a:rPr sz="1102" b="0">
+                <a:solidFill>
+                  <a:srgbClr val="2D2D2D"/>
+                </a:solidFill>
+                <a:latin typeface="Trust Hartford Sans"/>
+              </a:rPr>
+              <a:t>                                           notes, data-backed claims                      verified every number traces to data</a:t>
             </a:r>
           </a:p>
         </p:txBody>
@@ -16452,8 +16475,8 @@
         </p:nvSpPr>
         <p:spPr>
           <a:xfrm>
-            <a:off x="400000" y="3600000"/>
-            <a:ext cx="11400000" cy="2000000"/>
+            <a:off x="400000" y="3650000"/>
+            <a:ext cx="11400000" cy="2800000"/>
           </a:xfrm>
           <a:prstGeom prst="roundRect">
             <a:avLst/>
@@ -16480,7 +16503,7 @@
           </a:fontRef>
         </p:style>
         <p:txBody>
-          <a:bodyPr wrap="square" rtlCol="0" anchor="ctr"/>
+          <a:bodyPr rtlCol="0" anchor="ctr" lIns="180000" tIns="180000" rIns="180000" bIns="90000" wrap="square"/>
           <a:lstStyle/>
           <a:p>
             <a:pPr algn="ctr"/>
@@ -16489,8 +16512,25 @@
                 <a:solidFill>
                   <a:srgbClr val="E65100"/>
                 </a:solidFill>
-              </a:rPr>
-              <a:t>What We Rejected or Corrected From AI Suggestions</a:t>
+                <a:latin typeface="Trust Hartford Sans"/>
+              </a:rPr>
+              <a:t>What We Rejected or Corrected</a:t>
+            </a:r>
+          </a:p>
+          <a:p>
+            <a:pPr>
+              <a:spcBef>
+                <a:spcPts val="1000"/>
+              </a:spcBef>
+            </a:pPr>
+            <a:r>
+              <a:rPr sz="1200" b="0">
+                <a:solidFill>
+                  <a:srgbClr val="E65100"/>
+                </a:solidFill>
+                <a:latin typeface="Trust Hartford Sans"/>
+              </a:rPr>
+              <a:t>Fare calculations initially included tips, which inflated Queens averages ($66 vs correct $58). Caught during cross-check with Streamlit dashboard and corrected.</a:t>
             </a:r>
           </a:p>
           <a:p>
@@ -16500,12 +16540,45 @@
               </a:spcBef>
             </a:pPr>
             <a:r>
-              <a:rPr sz="1200">
-                <a:solidFill>
-                  <a:srgbClr val="2D2D2D"/>
-                </a:solidFill>
-              </a:rPr>
-              <a:t>[Describe corrections made, things that required manual verification, etc.]</a:t>
+              <a:rPr sz="1200" b="0">
+                <a:solidFill>
+                  <a:srgbClr val="E65100"/>
+                </a:solidFill>
+                <a:latin typeface="Trust Hartford Sans"/>
+              </a:rPr>
+              <a:t>Hourly earnings estimates used a 70% utilization assumption we couldn't verify from the data. Replaced with $/active-minute, which requires no assumptions.</a:t>
+            </a:r>
+          </a:p>
+          <a:p>
+            <a:pPr>
+              <a:spcBef>
+                <a:spcPts val="800"/>
+              </a:spcBef>
+            </a:pPr>
+            <a:r>
+              <a:rPr sz="1200" b="0">
+                <a:solidFill>
+                  <a:srgbClr val="E65100"/>
+                </a:solidFill>
+                <a:latin typeface="Trust Hartford Sans"/>
+              </a:rPr>
+              <a:t>Initial recommendation slide was overly descriptive ('the market was stable'). Reworked to be prescriptive with specific, data-backed actions for drivers.</a:t>
+            </a:r>
+          </a:p>
+          <a:p>
+            <a:pPr>
+              <a:spcBef>
+                <a:spcPts val="800"/>
+              </a:spcBef>
+            </a:pPr>
+            <a:r>
+              <a:rPr sz="1200" b="0">
+                <a:solidFill>
+                  <a:srgbClr val="E65100"/>
+                </a:solidFill>
+                <a:latin typeface="Trust Hartford Sans"/>
+              </a:rPr>
+              <a:t>All AI-generated code was reviewed, tested, and committed by team members. No AI output was used without independent verification.</a:t>
             </a:r>
           </a:p>
         </p:txBody>
@@ -17331,13 +17404,7 @@
       </p:sp>
       <p:sp>
         <p:nvSpPr>
-          <p:cNvPr id="5" name="Rounded Rectangle 4">
-            <a:extLst>
-              <a:ext uri="{FF2B5EF4-FFF2-40B4-BE49-F238E27FC236}">
-                <a16:creationId xmlns:a16="http://schemas.microsoft.com/office/drawing/2014/main" id="{E831FFAF-D961-34C9-4C81-8C1B9B8B0C43}"/>
-              </a:ext>
-            </a:extLst>
-          </p:cNvPr>
+          <p:cNvPr id="5" name="Rounded Rectangle 4"/>
           <p:cNvSpPr/>
           <p:nvPr/>
         </p:nvSpPr>
@@ -17349,9 +17416,7 @@
           <a:prstGeom prst="roundRect">
             <a:avLst/>
           </a:prstGeom>
-          <a:solidFill>
-            <a:srgbClr val="FCE4EC"/>
-          </a:solidFill>
+          <a:noFill/>
           <a:ln>
             <a:noFill/>
           </a:ln>
@@ -17371,46 +17436,25 @@
           </a:fontRef>
         </p:style>
         <p:txBody>
-          <a:bodyPr wrap="square" lIns="91440" tIns="45720" rIns="91440" bIns="45720" rtlCol="0" anchor="ctr"/>
+          <a:bodyPr rtlCol="0" anchor="ctr" lIns="180000" tIns="180000" rIns="180000" bIns="90000" wrap="square"/>
           <a:lstStyle/>
           <a:p>
             <a:pPr algn="ctr"/>
-            <a:endParaRPr lang="en-US" sz="1600" b="1">
-              <a:solidFill>
-                <a:srgbClr val="2D2D2D"/>
-              </a:solidFill>
-            </a:endParaRPr>
-          </a:p>
-          <a:p>
-            <a:pPr algn="ctr"/>
-            <a:r>
-              <a:rPr lang="en-US" sz="1900" b="1">
+            <a:r>
+              <a:rPr sz="1900" b="1">
                 <a:solidFill>
                   <a:srgbClr val="8B0138"/>
                 </a:solidFill>
-              </a:rPr>
-              <a:t> A single storm-hour during rush hour now costs more in lost revenue than several off-peak storm-hours combined.</a:t>
-            </a:r>
-          </a:p>
-          <a:p>
-            <a:pPr algn="ctr"/>
-            <a:endParaRPr lang="en-US">
-              <a:solidFill>
-                <a:srgbClr val="FFFFFF"/>
-              </a:solidFill>
-            </a:endParaRPr>
-          </a:p>
-        </p:txBody>
-      </p:sp>
-      <p:sp>
-        <p:nvSpPr>
-          <p:cNvPr id="6" name="Rounded Rectangle 5">
-            <a:extLst>
-              <a:ext uri="{FF2B5EF4-FFF2-40B4-BE49-F238E27FC236}">
-                <a16:creationId xmlns:a16="http://schemas.microsoft.com/office/drawing/2014/main" id="{94BAC692-A57D-6F57-D8E9-813F7DA39B7C}"/>
-              </a:ext>
-            </a:extLst>
-          </p:cNvPr>
+                <a:latin typeface="Trust Hartford Sans"/>
+              </a:rPr>
+              <a:t>Drivers who stay on the road during adverse weather earn more per minute. The revenue impact isn't about price; it's about how many drivers are available.</a:t>
+            </a:r>
+          </a:p>
+        </p:txBody>
+      </p:sp>
+      <p:sp>
+        <p:nvSpPr>
+          <p:cNvPr id="6" name="Rounded Rectangle 5"/>
           <p:cNvSpPr/>
           <p:nvPr/>
         </p:nvSpPr>
@@ -17422,9 +17466,7 @@
           <a:prstGeom prst="roundRect">
             <a:avLst/>
           </a:prstGeom>
-          <a:solidFill>
-            <a:srgbClr val="E3F2FD"/>
-          </a:solidFill>
+          <a:noFill/>
           <a:ln>
             <a:noFill/>
           </a:ln>
@@ -17444,7 +17486,7 @@
           </a:fontRef>
         </p:style>
         <p:txBody>
-          <a:bodyPr wrap="square" rtlCol="0" anchor="ctr"/>
+          <a:bodyPr rtlCol="0" anchor="ctr" lIns="180000" tIns="180000" rIns="180000" bIns="90000" wrap="square"/>
           <a:lstStyle/>
           <a:p>
             <a:pPr algn="ctr"/>
@@ -17453,17 +17495,18 @@
                 <a:solidFill>
                   <a:srgbClr val="0D47A1"/>
                 </a:solidFill>
+                <a:latin typeface="Trust Hartford Sans"/>
               </a:rPr>
               <a:t>38M+</a:t>
             </a:r>
           </a:p>
           <a:p>
-            <a:pPr algn="ctr"/>
-            <a:r>
-              <a:rPr sz="1200">
+            <a:r>
+              <a:rPr sz="1200" b="0">
                 <a:solidFill>
                   <a:srgbClr val="555555"/>
                 </a:solidFill>
+                <a:latin typeface="Trust Hartford Sans"/>
               </a:rPr>
               <a:t>Trip Records Analyzed</a:t>
             </a:r>
@@ -17472,13 +17515,7 @@
       </p:sp>
       <p:sp>
         <p:nvSpPr>
-          <p:cNvPr id="7" name="Rounded Rectangle 6">
-            <a:extLst>
-              <a:ext uri="{FF2B5EF4-FFF2-40B4-BE49-F238E27FC236}">
-                <a16:creationId xmlns:a16="http://schemas.microsoft.com/office/drawing/2014/main" id="{92F307B3-32E8-4798-07AA-CE89169BE790}"/>
-              </a:ext>
-            </a:extLst>
-          </p:cNvPr>
+          <p:cNvPr id="7" name="Rounded Rectangle 6"/>
           <p:cNvSpPr/>
           <p:nvPr/>
         </p:nvSpPr>
@@ -17490,9 +17527,7 @@
           <a:prstGeom prst="roundRect">
             <a:avLst/>
           </a:prstGeom>
-          <a:solidFill>
-            <a:srgbClr val="E3F2FD"/>
-          </a:solidFill>
+          <a:noFill/>
           <a:ln>
             <a:noFill/>
           </a:ln>
@@ -17512,7 +17547,7 @@
           </a:fontRef>
         </p:style>
         <p:txBody>
-          <a:bodyPr wrap="square" rtlCol="0" anchor="ctr"/>
+          <a:bodyPr rtlCol="0" anchor="ctr" lIns="180000" tIns="180000" rIns="180000" bIns="90000" wrap="square"/>
           <a:lstStyle/>
           <a:p>
             <a:pPr algn="ctr"/>
@@ -17521,17 +17556,18 @@
                 <a:solidFill>
                   <a:srgbClr val="0D47A1"/>
                 </a:solidFill>
+                <a:latin typeface="Trust Hartford Sans"/>
               </a:rPr>
               <a:t>10 months</a:t>
             </a:r>
           </a:p>
           <a:p>
-            <a:pPr algn="ctr"/>
-            <a:r>
-              <a:rPr sz="1200">
+            <a:r>
+              <a:rPr sz="1200" b="0">
                 <a:solidFill>
                   <a:srgbClr val="555555"/>
                 </a:solidFill>
+                <a:latin typeface="Trust Hartford Sans"/>
               </a:rPr>
               <a:t>Jan-May 2025 vs 2026</a:t>
             </a:r>
@@ -17540,13 +17576,7 @@
       </p:sp>
       <p:sp>
         <p:nvSpPr>
-          <p:cNvPr id="8" name="Rounded Rectangle 7">
-            <a:extLst>
-              <a:ext uri="{FF2B5EF4-FFF2-40B4-BE49-F238E27FC236}">
-                <a16:creationId xmlns:a16="http://schemas.microsoft.com/office/drawing/2014/main" id="{53CA5D5C-F525-5CEA-D403-7EDE5D23B2FF}"/>
-              </a:ext>
-            </a:extLst>
-          </p:cNvPr>
+          <p:cNvPr id="8" name="Rounded Rectangle 7"/>
           <p:cNvSpPr/>
           <p:nvPr/>
         </p:nvSpPr>
@@ -17558,9 +17588,7 @@
           <a:prstGeom prst="roundRect">
             <a:avLst/>
           </a:prstGeom>
-          <a:solidFill>
-            <a:srgbClr val="E3F2FD"/>
-          </a:solidFill>
+          <a:noFill/>
           <a:ln>
             <a:noFill/>
           </a:ln>
@@ -17580,7 +17608,7 @@
           </a:fontRef>
         </p:style>
         <p:txBody>
-          <a:bodyPr wrap="square" rtlCol="0" anchor="ctr"/>
+          <a:bodyPr rtlCol="0" anchor="ctr" lIns="180000" tIns="180000" rIns="180000" bIns="90000" wrap="square"/>
           <a:lstStyle/>
           <a:p>
             <a:pPr algn="ctr"/>
@@ -17589,17 +17617,18 @@
                 <a:solidFill>
                   <a:srgbClr val="0D47A1"/>
                 </a:solidFill>
+                <a:latin typeface="Trust Hartford Sans"/>
               </a:rPr>
               <a:t>5 boroughs</a:t>
             </a:r>
           </a:p>
           <a:p>
-            <a:pPr algn="ctr"/>
-            <a:r>
-              <a:rPr sz="1200">
+            <a:r>
+              <a:rPr sz="1200" b="0">
                 <a:solidFill>
                   <a:srgbClr val="555555"/>
                 </a:solidFill>
+                <a:latin typeface="Trust Hartford Sans"/>
               </a:rPr>
               <a:t>Weather Impact Compared</a:t>
             </a:r>
@@ -17608,13 +17637,7 @@
       </p:sp>
       <p:sp>
         <p:nvSpPr>
-          <p:cNvPr id="9" name="Rounded Rectangle 8">
-            <a:extLst>
-              <a:ext uri="{FF2B5EF4-FFF2-40B4-BE49-F238E27FC236}">
-                <a16:creationId xmlns:a16="http://schemas.microsoft.com/office/drawing/2014/main" id="{88EA5623-CF14-F675-B41F-9D11B723E59E}"/>
-              </a:ext>
-            </a:extLst>
-          </p:cNvPr>
+          <p:cNvPr id="9" name="Rounded Rectangle 8"/>
           <p:cNvSpPr/>
           <p:nvPr/>
         </p:nvSpPr>
@@ -17648,36 +17671,34 @@
           </a:fontRef>
         </p:style>
         <p:txBody>
-          <a:bodyPr wrap="square" lIns="91440" tIns="45720" rIns="91440" bIns="45720" rtlCol="0" anchor="ctr"/>
+          <a:bodyPr rtlCol="0" anchor="ctr" lIns="180000" tIns="180000" rIns="180000" bIns="90000" wrap="square"/>
           <a:lstStyle/>
           <a:p>
             <a:pPr algn="ctr"/>
             <a:r>
-              <a:rPr lang="en-US" b="1">
+              <a:rPr sz="1600" b="1">
+                <a:solidFill>
+                  <a:srgbClr val="2E7D32"/>
+                </a:solidFill>
+                <a:latin typeface="Trust Hartford Sans"/>
+              </a:rPr>
+              <a:t>Business Insight</a:t>
+            </a:r>
+          </a:p>
+          <a:p>
+            <a:pPr>
+              <a:spcBef>
+                <a:spcPts val="800"/>
+              </a:spcBef>
+            </a:pPr>
+            <a:r>
+              <a:rPr sz="1400" b="0">
                 <a:solidFill>
                   <a:srgbClr val="2D805D"/>
                 </a:solidFill>
-              </a:rPr>
-              <a:t>Business Insight</a:t>
-            </a:r>
-          </a:p>
-          <a:p>
-            <a:pPr algn="ctr"/>
-            <a:endParaRPr lang="en-US" b="1">
-              <a:solidFill>
-                <a:srgbClr val="2D805D"/>
-              </a:solidFill>
-            </a:endParaRPr>
-          </a:p>
-          <a:p>
-            <a:pPr algn="ctr"/>
-            <a:r>
-              <a:rPr lang="en-US">
-                <a:solidFill>
-                  <a:srgbClr val="2D805D"/>
-                </a:solidFill>
-              </a:rPr>
-              <a:t>Pre-position vehicles before forecasted storms, prioritize rush-hour coverage, and consider dynamic incentives for drivers to stay on the road during adverse conditions.</a:t>
+                <a:latin typeface="Trust Hartford Sans"/>
+              </a:rPr>
+              <a:t>During rain, prioritize Brooklyn where demand and earnings both surge. During snow, drivers who stay out earn 8-29% more per active minute across all boroughs. During clear weather, choose Manhattan for volume or Queens for higher per-trip returns.</a:t>
             </a:r>
           </a:p>
         </p:txBody>

</xml_diff>

<commit_message>
Fix slide 5 headline, redo AI disclosure with 3-card theme layout
Slide 5: headline now about volume not price, removes supply claim.
Slide 21: three-card layout (blue/green/orange) matching deck theme,
no specific tool names, focuses on what/how verified/what corrected.
</commit_message>
<xml_diff>
--- a/docs/Capstone_Presentation (10).pptx
+++ b/docs/Capstone_Presentation (10).pptx
@@ -2745,9 +2745,9 @@
           <a:lstStyle/>
           <a:p>
             <a:r>
-              <a:t>ORLANDO: Here's the headline from our analysis. We found that adverse weather doesn't reduce what a ride costs. It reduces how many rides happen. But for the drivers who stay on the road, they actually earn more per minute of active driving time.
-We analyzed over 38 million trips across 10 months and all five boroughs. The key insight is that each weather condition calls for a different positioning strategy.
-During rain, Brooklyn is the clear winner: demand surges 27 percent and per-minute earnings rise 11 percent. During snow, earnings per active minute rise in every borough, from 8 percent in Manhattan to 29 percent in the Bronx. And during clear weather, which is 94.5 percent of all hours, drivers choose between Manhattan's unmatched volume or Queens' 14 percent per-minute premium on longer trips.
+              <a:t>ORLANDO: Here's the headline from our analysis. Adverse weather doesn't change what a ride costs. Fares stay essentially flat across all boroughs regardless of conditions. What changes is how many rides happen, and that impact is not spread evenly. It concentrates in specific boroughs and specific hours.
+We analyzed over 38 million trips across 10 months and all five boroughs. The key insight is that each weather condition creates a different positioning opportunity.
+During rain, Brooklyn demand surges 27 percent and per-minute earnings rise 11 percent. During snow, per-minute earnings rise in every borough, from 8 percent in Manhattan to 29 percent in the Bronx. And during clear weather, which is 94.5 percent of all hours, drivers choose between Manhattan's unmatched volume or Queens' 14 percent per-minute premium on longer trips.
 The bottom line: weather creates positioning opportunities, not just risk.</a:t>
             </a:r>
             <a:endParaRPr lang="en-US">
@@ -16236,60 +16236,8 @@
         </p:nvSpPr>
         <p:spPr>
           <a:xfrm>
-            <a:off x="400000" y="1100000"/>
-            <a:ext cx="11400000" cy="500000"/>
-          </a:xfrm>
-          <a:prstGeom prst="roundRect">
-            <a:avLst/>
-          </a:prstGeom>
-          <a:solidFill>
-            <a:srgbClr val="0D47A1"/>
-          </a:solidFill>
-          <a:ln>
-            <a:noFill/>
-          </a:ln>
-        </p:spPr>
-        <p:style>
-          <a:lnRef idx="1">
-            <a:schemeClr val="accent1"/>
-          </a:lnRef>
-          <a:fillRef idx="3">
-            <a:schemeClr val="accent1"/>
-          </a:fillRef>
-          <a:effectRef idx="2">
-            <a:schemeClr val="accent1"/>
-          </a:effectRef>
-          <a:fontRef idx="minor">
-            <a:schemeClr val="lt1"/>
-          </a:fontRef>
-        </p:style>
-        <p:txBody>
-          <a:bodyPr rtlCol="0" anchor="ctr" lIns="180000" tIns="180000" rIns="180000" bIns="90000" wrap="square"/>
-          <a:lstStyle/>
-          <a:p>
-            <a:pPr algn="ctr"/>
-            <a:r>
-              <a:rPr sz="1200" b="1">
-                <a:solidFill>
-                  <a:srgbClr val="FFFFFF"/>
-                </a:solidFill>
-                <a:latin typeface="Trust Hartford Sans"/>
-              </a:rPr>
-              <a:t>Where We Used AI                    What For                                        How We Verified</a:t>
-            </a:r>
-          </a:p>
-        </p:txBody>
-      </p:sp>
-      <p:sp>
-        <p:nvSpPr>
-          <p:cNvPr id="6" name="Rounded Rectangle 5"/>
-          <p:cNvSpPr/>
-          <p:nvPr/>
-        </p:nvSpPr>
-        <p:spPr>
-          <a:xfrm>
-            <a:off x="400000" y="1650000"/>
-            <a:ext cx="11400000" cy="550000"/>
+            <a:off x="297780" y="1200000"/>
+            <a:ext cx="3755195" cy="4200000"/>
           </a:xfrm>
           <a:prstGeom prst="roundRect">
             <a:avLst/>
@@ -16321,105 +16269,97 @@
           <a:p>
             <a:pPr algn="ctr"/>
             <a:r>
-              <a:rPr sz="1102" b="0">
-                <a:solidFill>
-                  <a:srgbClr val="2D2D2D"/>
+              <a:rPr sz="1600" b="1">
+                <a:solidFill>
+                  <a:srgbClr val="0D47A1"/>
                 </a:solidFill>
                 <a:latin typeface="Trust Hartford Sans"/>
               </a:rPr>
-              <a:t>Claude Code                         Pipeline orchestration, dbt models,       Ran full pipeline end-to-end, verified</a:t>
-            </a:r>
-          </a:p>
-          <a:p>
-            <a:r>
-              <a:rPr sz="1102" b="0">
-                <a:solidFill>
-                  <a:srgbClr val="2D2D2D"/>
+              <a:t>Where We Used AI</a:t>
+            </a:r>
+          </a:p>
+          <a:p>
+            <a:pPr>
+              <a:spcBef>
+                <a:spcPts val="1200"/>
+              </a:spcBef>
+            </a:pPr>
+            <a:r>
+              <a:rPr sz="1400" b="0">
+                <a:solidFill>
+                  <a:srgbClr val="2F63AF"/>
                 </a:solidFill>
                 <a:latin typeface="Trust Hartford Sans"/>
               </a:rPr>
-              <a:t>                                           SQL transformations                              row counts against source files</a:t>
-            </a:r>
-          </a:p>
-        </p:txBody>
-      </p:sp>
-      <p:sp>
-        <p:nvSpPr>
-          <p:cNvPr id="7" name="Rounded Rectangle 6"/>
+              <a:t>Pipeline development and SQL transformations</a:t>
+            </a:r>
+          </a:p>
+          <a:p>
+            <a:pPr>
+              <a:spcBef>
+                <a:spcPts val="800"/>
+              </a:spcBef>
+            </a:pPr>
+            <a:r>
+              <a:rPr sz="1400" b="0">
+                <a:solidFill>
+                  <a:srgbClr val="2F63AF"/>
+                </a:solidFill>
+                <a:latin typeface="Trust Hartford Sans"/>
+              </a:rPr>
+              <a:t>Streamlit visualizations and chart logic</a:t>
+            </a:r>
+          </a:p>
+          <a:p>
+            <a:pPr>
+              <a:spcBef>
+                <a:spcPts val="800"/>
+              </a:spcBef>
+            </a:pPr>
+            <a:r>
+              <a:rPr sz="1400" b="0">
+                <a:solidFill>
+                  <a:srgbClr val="2F63AF"/>
+                </a:solidFill>
+                <a:latin typeface="Trust Hartford Sans"/>
+              </a:rPr>
+              <a:t>Data analysis and revenue calculations</a:t>
+            </a:r>
+          </a:p>
+          <a:p>
+            <a:pPr>
+              <a:spcBef>
+                <a:spcPts val="800"/>
+              </a:spcBef>
+            </a:pPr>
+            <a:r>
+              <a:rPr sz="1400" b="0">
+                <a:solidFill>
+                  <a:srgbClr val="2F63AF"/>
+                </a:solidFill>
+                <a:latin typeface="Trust Hartford Sans"/>
+              </a:rPr>
+              <a:t>Presentation content and speaker notes</a:t>
+            </a:r>
+          </a:p>
+        </p:txBody>
+      </p:sp>
+      <p:sp>
+        <p:nvSpPr>
+          <p:cNvPr id="6" name="Rounded Rectangle 5"/>
           <p:cNvSpPr/>
           <p:nvPr/>
         </p:nvSpPr>
         <p:spPr>
           <a:xfrm>
-            <a:off x="400000" y="2250000"/>
-            <a:ext cx="11400000" cy="550000"/>
-          </a:xfrm>
-          <a:prstGeom prst="roundRect">
-            <a:avLst/>
-          </a:prstGeom>
-          <a:noFill/>
-          <a:ln>
-            <a:noFill/>
-          </a:ln>
-        </p:spPr>
-        <p:style>
-          <a:lnRef idx="1">
-            <a:schemeClr val="accent1"/>
-          </a:lnRef>
-          <a:fillRef idx="3">
-            <a:schemeClr val="accent1"/>
-          </a:fillRef>
-          <a:effectRef idx="2">
-            <a:schemeClr val="accent1"/>
-          </a:effectRef>
-          <a:fontRef idx="minor">
-            <a:schemeClr val="lt1"/>
-          </a:fontRef>
-        </p:style>
-        <p:txBody>
-          <a:bodyPr rtlCol="0" anchor="ctr" lIns="180000" tIns="180000" rIns="180000" bIns="90000" wrap="square"/>
-          <a:lstStyle/>
-          <a:p>
-            <a:pPr algn="ctr"/>
-            <a:r>
-              <a:rPr sz="1102" b="0">
-                <a:solidFill>
-                  <a:srgbClr val="2D2D2D"/>
-                </a:solidFill>
-                <a:latin typeface="Trust Hartford Sans"/>
-              </a:rPr>
-              <a:t>Claude Code                         Streamlit visualizations, chart            Validated all calculations against</a:t>
-            </a:r>
-          </a:p>
-          <a:p>
-            <a:r>
-              <a:rPr sz="1102" b="0">
-                <a:solidFill>
-                  <a:srgbClr val="2D2D2D"/>
-                </a:solidFill>
-                <a:latin typeface="Trust Hartford Sans"/>
-              </a:rPr>
-              <a:t>                                           logic, data analysis                                 raw data and Tableau results</a:t>
-            </a:r>
-          </a:p>
-        </p:txBody>
-      </p:sp>
-      <p:sp>
-        <p:nvSpPr>
-          <p:cNvPr id="8" name="Rounded Rectangle 7"/>
-          <p:cNvSpPr/>
-          <p:nvPr/>
-        </p:nvSpPr>
-        <p:spPr>
-          <a:xfrm>
-            <a:off x="400000" y="2850000"/>
-            <a:ext cx="11400000" cy="550000"/>
+            <a:off x="4222879" y="1200000"/>
+            <a:ext cx="3748539" cy="4200000"/>
           </a:xfrm>
           <a:prstGeom prst="roundRect">
             <a:avLst/>
           </a:prstGeom>
           <a:solidFill>
-            <a:srgbClr val="E3F2FD"/>
+            <a:srgbClr val="E8F5E9"/>
           </a:solidFill>
           <a:ln>
             <a:noFill/>
@@ -16445,38 +16385,91 @@
           <a:p>
             <a:pPr algn="ctr"/>
             <a:r>
-              <a:rPr sz="1102" b="0">
-                <a:solidFill>
-                  <a:srgbClr val="2D2D2D"/>
+              <a:rPr sz="1600" b="1">
+                <a:solidFill>
+                  <a:srgbClr val="2E7D32"/>
                 </a:solidFill>
                 <a:latin typeface="Trust Hartford Sans"/>
               </a:rPr>
-              <a:t>Claude Code                         Slide content drafting, speaker             Rewrote and revised all content;</a:t>
-            </a:r>
-          </a:p>
-          <a:p>
-            <a:r>
-              <a:rPr sz="1102" b="0">
-                <a:solidFill>
-                  <a:srgbClr val="2D2D2D"/>
+              <a:t>How We Verified</a:t>
+            </a:r>
+          </a:p>
+          <a:p>
+            <a:pPr>
+              <a:spcBef>
+                <a:spcPts val="1200"/>
+              </a:spcBef>
+            </a:pPr>
+            <a:r>
+              <a:rPr sz="1400" b="0">
+                <a:solidFill>
+                  <a:srgbClr val="2D805D"/>
                 </a:solidFill>
                 <a:latin typeface="Trust Hartford Sans"/>
               </a:rPr>
-              <a:t>                                           notes, data-backed claims                      verified every number traces to data</a:t>
-            </a:r>
-          </a:p>
-        </p:txBody>
-      </p:sp>
-      <p:sp>
-        <p:nvSpPr>
-          <p:cNvPr id="9" name="Rounded Rectangle 8"/>
+              <a:t>Ran full pipeline end-to-end and reconciled row counts against source</a:t>
+            </a:r>
+          </a:p>
+          <a:p>
+            <a:pPr>
+              <a:spcBef>
+                <a:spcPts val="800"/>
+              </a:spcBef>
+            </a:pPr>
+            <a:r>
+              <a:rPr sz="1400" b="0">
+                <a:solidFill>
+                  <a:srgbClr val="2D805D"/>
+                </a:solidFill>
+                <a:latin typeface="Trust Hartford Sans"/>
+              </a:rPr>
+              <a:t>Cross-checked all calculations against raw data and Tableau results</a:t>
+            </a:r>
+          </a:p>
+          <a:p>
+            <a:pPr>
+              <a:spcBef>
+                <a:spcPts val="800"/>
+              </a:spcBef>
+            </a:pPr>
+            <a:r>
+              <a:rPr sz="1400" b="0">
+                <a:solidFill>
+                  <a:srgbClr val="2D805D"/>
+                </a:solidFill>
+                <a:latin typeface="Trust Hartford Sans"/>
+              </a:rPr>
+              <a:t>Reviewed and revised all generated content before committing</a:t>
+            </a:r>
+          </a:p>
+          <a:p>
+            <a:pPr>
+              <a:spcBef>
+                <a:spcPts val="800"/>
+              </a:spcBef>
+            </a:pPr>
+            <a:r>
+              <a:rPr sz="1400" b="0">
+                <a:solidFill>
+                  <a:srgbClr val="2D805D"/>
+                </a:solidFill>
+                <a:latin typeface="Trust Hartford Sans"/>
+              </a:rPr>
+              <a:t>Every number on every slide traces back to a verifiable query</a:t>
+            </a:r>
+          </a:p>
+        </p:txBody>
+      </p:sp>
+      <p:sp>
+        <p:nvSpPr>
+          <p:cNvPr id="7" name="Rounded Rectangle 6"/>
           <p:cNvSpPr/>
           <p:nvPr/>
         </p:nvSpPr>
         <p:spPr>
           <a:xfrm>
-            <a:off x="400000" y="3650000"/>
-            <a:ext cx="11400000" cy="2800000"/>
+            <a:off x="8293073" y="1200000"/>
+            <a:ext cx="3404708" cy="4200000"/>
           </a:xfrm>
           <a:prstGeom prst="roundRect">
             <a:avLst/>
@@ -16508,29 +16501,29 @@
           <a:p>
             <a:pPr algn="ctr"/>
             <a:r>
-              <a:rPr sz="1400" b="1">
+              <a:rPr sz="1600" b="1">
                 <a:solidFill>
                   <a:srgbClr val="E65100"/>
                 </a:solidFill>
                 <a:latin typeface="Trust Hartford Sans"/>
               </a:rPr>
-              <a:t>What We Rejected or Corrected</a:t>
+              <a:t>What We Corrected</a:t>
             </a:r>
           </a:p>
           <a:p>
             <a:pPr>
               <a:spcBef>
-                <a:spcPts val="1000"/>
+                <a:spcPts val="1200"/>
               </a:spcBef>
             </a:pPr>
             <a:r>
-              <a:rPr sz="1200" b="0">
+              <a:rPr sz="1400" b="0">
                 <a:solidFill>
                   <a:srgbClr val="E65100"/>
                 </a:solidFill>
                 <a:latin typeface="Trust Hartford Sans"/>
               </a:rPr>
-              <a:t>Fare calculations initially included tips, which inflated Queens averages ($66 vs correct $58). Caught during cross-check with Streamlit dashboard and corrected.</a:t>
+              <a:t>Fare calculations initially included tips, inflating averages. Caught and corrected.</a:t>
             </a:r>
           </a:p>
           <a:p>
@@ -16540,13 +16533,13 @@
               </a:spcBef>
             </a:pPr>
             <a:r>
-              <a:rPr sz="1200" b="0">
+              <a:rPr sz="1400" b="0">
                 <a:solidFill>
                   <a:srgbClr val="E65100"/>
                 </a:solidFill>
                 <a:latin typeface="Trust Hartford Sans"/>
               </a:rPr>
-              <a:t>Hourly earnings estimates used a 70% utilization assumption we couldn't verify from the data. Replaced with $/active-minute, which requires no assumptions.</a:t>
+              <a:t>Hourly earnings used an unverifiable utilization assumption. Replaced with $/active-minute.</a:t>
             </a:r>
           </a:p>
           <a:p>
@@ -16556,29 +16549,65 @@
               </a:spcBef>
             </a:pPr>
             <a:r>
-              <a:rPr sz="1200" b="0">
+              <a:rPr sz="1400" b="0">
                 <a:solidFill>
                   <a:srgbClr val="E65100"/>
                 </a:solidFill>
                 <a:latin typeface="Trust Hartford Sans"/>
               </a:rPr>
-              <a:t>Initial recommendation slide was overly descriptive ('the market was stable'). Reworked to be prescriptive with specific, data-backed actions for drivers.</a:t>
-            </a:r>
-          </a:p>
-          <a:p>
-            <a:pPr>
-              <a:spcBef>
-                <a:spcPts val="800"/>
-              </a:spcBef>
-            </a:pPr>
-            <a:r>
-              <a:rPr sz="1200" b="0">
-                <a:solidFill>
-                  <a:srgbClr val="E65100"/>
+              <a:t>Initial summary slide was descriptive. Reworked to be prescriptive with data-backed actions.</a:t>
+            </a:r>
+          </a:p>
+        </p:txBody>
+      </p:sp>
+      <p:sp>
+        <p:nvSpPr>
+          <p:cNvPr id="8" name="Rounded Rectangle 7"/>
+          <p:cNvSpPr/>
+          <p:nvPr/>
+        </p:nvSpPr>
+        <p:spPr>
+          <a:xfrm>
+            <a:off x="400000" y="5600000"/>
+            <a:ext cx="11400000" cy="600000"/>
+          </a:xfrm>
+          <a:prstGeom prst="roundRect">
+            <a:avLst/>
+          </a:prstGeom>
+          <a:solidFill>
+            <a:srgbClr val="8B0138"/>
+          </a:solidFill>
+          <a:ln>
+            <a:noFill/>
+          </a:ln>
+        </p:spPr>
+        <p:style>
+          <a:lnRef idx="1">
+            <a:schemeClr val="accent1"/>
+          </a:lnRef>
+          <a:fillRef idx="3">
+            <a:schemeClr val="accent1"/>
+          </a:fillRef>
+          <a:effectRef idx="2">
+            <a:schemeClr val="accent1"/>
+          </a:effectRef>
+          <a:fontRef idx="minor">
+            <a:schemeClr val="lt1"/>
+          </a:fontRef>
+        </p:style>
+        <p:txBody>
+          <a:bodyPr rtlCol="0" anchor="ctr" lIns="200000" tIns="120000" rIns="180000" bIns="90000" wrap="square"/>
+          <a:lstStyle/>
+          <a:p>
+            <a:pPr algn="ctr"/>
+            <a:r>
+              <a:rPr sz="1300" b="1">
+                <a:solidFill>
+                  <a:srgbClr val="FFFFFF"/>
                 </a:solidFill>
                 <a:latin typeface="Trust Hartford Sans"/>
               </a:rPr>
-              <a:t>All AI-generated code was reviewed, tested, and committed by team members. No AI output was used without independent verification.</a:t>
+              <a:t>AI accelerated development. Human judgment drove every analytical decision and verified every output.</a:t>
             </a:r>
           </a:p>
         </p:txBody>
@@ -17447,7 +17476,7 @@
                 </a:solidFill>
                 <a:latin typeface="Trust Hartford Sans"/>
               </a:rPr>
-              <a:t>Drivers who stay on the road during adverse weather earn more per minute. The revenue impact isn't about price; it's about how many drivers are available.</a:t>
+              <a:t>Weather doesn't change what a ride costs. It changes how many rides happen, and that impact is concentrated in the hours and boroughs that matter most.</a:t>
             </a:r>
           </a:p>
         </p:txBody>
@@ -17698,7 +17727,7 @@
                 </a:solidFill>
                 <a:latin typeface="Trust Hartford Sans"/>
               </a:rPr>
-              <a:t>During rain, prioritize Brooklyn where demand and earnings both surge. During snow, drivers who stay out earn 8-29% more per active minute across all boroughs. During clear weather, choose Manhattan for volume or Queens for higher per-trip returns.</a:t>
+              <a:t>During rain, prioritize Brooklyn where demand and earnings both surge. During snow, per-minute earnings rise 8-29% across all boroughs. During clear weather, choose Manhattan for volume or Queens for higher per-trip returns.</a:t>
             </a:r>
           </a:p>
         </p:txBody>

</xml_diff>